<commit_message>
Add project author attribution
</commit_message>
<xml_diff>
--- a/docs/CORNERSTONE_Wafer_Post-Processing_Suite_Overview_v0.4.0.pptx
+++ b/docs/CORNERSTONE_Wafer_Post-Processing_Suite_Overview_v0.4.0.pptx
@@ -2,27 +2,27 @@
 <file path=ppt/presentation.xml><?xml version="1.0" encoding="utf-8"?>
 <p:presentation xmlns:p="http://schemas.openxmlformats.org/presentationml/2006/main">
   <p:sldMasterIdLst>
-    <p:sldMasterId xmlns:r="http://schemas.openxmlformats.org/officeDocument/2006/relationships" id="2147483648" r:id="R05abb760d6c94b8d"/>
+    <p:sldMasterId xmlns:r="http://schemas.openxmlformats.org/officeDocument/2006/relationships" id="2147483648" r:id="R3b5b3bc540384d97"/>
   </p:sldMasterIdLst>
   <p:notesMasterIdLst>
-    <p:notesMasterId xmlns:r="http://schemas.openxmlformats.org/officeDocument/2006/relationships" r:id="R3be78e85b47b433a"/>
+    <p:notesMasterId xmlns:r="http://schemas.openxmlformats.org/officeDocument/2006/relationships" r:id="R10e4fdc55ef4452f"/>
   </p:notesMasterIdLst>
   <p:sldIdLst>
-    <p:sldId xmlns:r="http://schemas.openxmlformats.org/officeDocument/2006/relationships" id="256" r:id="R4aa202f969ff4919"/>
-    <p:sldId xmlns:r="http://schemas.openxmlformats.org/officeDocument/2006/relationships" id="257" r:id="R81ad3ab13cfd40fd"/>
-    <p:sldId xmlns:r="http://schemas.openxmlformats.org/officeDocument/2006/relationships" id="258" r:id="Rce26e67b63844ecf"/>
-    <p:sldId xmlns:r="http://schemas.openxmlformats.org/officeDocument/2006/relationships" id="259" r:id="R201fce0aabd04248"/>
-    <p:sldId xmlns:r="http://schemas.openxmlformats.org/officeDocument/2006/relationships" id="260" r:id="R428b792d2cf0473a"/>
-    <p:sldId xmlns:r="http://schemas.openxmlformats.org/officeDocument/2006/relationships" id="261" r:id="R0124ee28bc074895"/>
-    <p:sldId xmlns:r="http://schemas.openxmlformats.org/officeDocument/2006/relationships" id="262" r:id="R8a3718d22e7646b9"/>
-    <p:sldId xmlns:r="http://schemas.openxmlformats.org/officeDocument/2006/relationships" id="263" r:id="R62fb36d1e0ee48d8"/>
-    <p:sldId xmlns:r="http://schemas.openxmlformats.org/officeDocument/2006/relationships" id="264" r:id="Red9115efe4af4af9"/>
-    <p:sldId xmlns:r="http://schemas.openxmlformats.org/officeDocument/2006/relationships" id="265" r:id="R27ded546762a4032"/>
-    <p:sldId xmlns:r="http://schemas.openxmlformats.org/officeDocument/2006/relationships" id="266" r:id="Rb34436b9fbaa43bb"/>
-    <p:sldId xmlns:r="http://schemas.openxmlformats.org/officeDocument/2006/relationships" id="267" r:id="R22598b1257fa4b3b"/>
-    <p:sldId xmlns:r="http://schemas.openxmlformats.org/officeDocument/2006/relationships" id="268" r:id="Ra0725e9f9b2c4798"/>
-    <p:sldId xmlns:r="http://schemas.openxmlformats.org/officeDocument/2006/relationships" id="269" r:id="Ra4601669d7c84666"/>
-    <p:sldId xmlns:r="http://schemas.openxmlformats.org/officeDocument/2006/relationships" id="270" r:id="R13a62c7e05294845"/>
+    <p:sldId xmlns:r="http://schemas.openxmlformats.org/officeDocument/2006/relationships" id="256" r:id="R90b6db40d5e34bd5"/>
+    <p:sldId xmlns:r="http://schemas.openxmlformats.org/officeDocument/2006/relationships" id="257" r:id="R21baccf0218e434a"/>
+    <p:sldId xmlns:r="http://schemas.openxmlformats.org/officeDocument/2006/relationships" id="258" r:id="R7171048393a84026"/>
+    <p:sldId xmlns:r="http://schemas.openxmlformats.org/officeDocument/2006/relationships" id="259" r:id="R4fd303db4d0f4974"/>
+    <p:sldId xmlns:r="http://schemas.openxmlformats.org/officeDocument/2006/relationships" id="260" r:id="Rfcd7e8544f034afc"/>
+    <p:sldId xmlns:r="http://schemas.openxmlformats.org/officeDocument/2006/relationships" id="261" r:id="R9bcfcf02ba21446f"/>
+    <p:sldId xmlns:r="http://schemas.openxmlformats.org/officeDocument/2006/relationships" id="262" r:id="R783c50c338d44397"/>
+    <p:sldId xmlns:r="http://schemas.openxmlformats.org/officeDocument/2006/relationships" id="263" r:id="Rb4a38deb4b0b455d"/>
+    <p:sldId xmlns:r="http://schemas.openxmlformats.org/officeDocument/2006/relationships" id="264" r:id="R8ba646419b9447a7"/>
+    <p:sldId xmlns:r="http://schemas.openxmlformats.org/officeDocument/2006/relationships" id="265" r:id="R4f0ae3f396ad442a"/>
+    <p:sldId xmlns:r="http://schemas.openxmlformats.org/officeDocument/2006/relationships" id="266" r:id="R6d56338a2907432f"/>
+    <p:sldId xmlns:r="http://schemas.openxmlformats.org/officeDocument/2006/relationships" id="267" r:id="R064c52b9159e4306"/>
+    <p:sldId xmlns:r="http://schemas.openxmlformats.org/officeDocument/2006/relationships" id="268" r:id="Rf3ee11a6973e4fed"/>
+    <p:sldId xmlns:r="http://schemas.openxmlformats.org/officeDocument/2006/relationships" id="269" r:id="Reba206cfdb0f4f2e"/>
+    <p:sldId xmlns:r="http://schemas.openxmlformats.org/officeDocument/2006/relationships" id="270" r:id="R34e33c1a11464467"/>
   </p:sldIdLst>
   <p:sldSz cx="12192000" cy="6858000"/>
   <p:notesSz cx="6858000" cy="9144000"/>
@@ -456,7 +456,7 @@
           <a:lstStyle xmlns:a="http://schemas.openxmlformats.org/drawingml/2006/main"/>
           <a:p xmlns:a="http://schemas.openxmlformats.org/drawingml/2006/main">
             <a:r>
-              <a:t>Open by framing this as a shared engineering workflow, not simply a new interface. The objective is to make wafer measurements easier to process, compare, explain, and reuse across teams. Mention that this deck covers the working local v0.4.0 candidate and the proposal for controlled team adoption.</a:t>
+              <a:t>Introduce yourself as Aiman Hazim Shafizam, Research Technician in Testing and Characterisation at CORNERSTONE. Open by framing this as a shared engineering workflow, not simply a new interface. The objective is to make wafer measurements easier to process, compare, explain, and reuse across teams. Mention that this deck covers the published v0.4.0 release and the proposal for controlled team adoption.</a:t>
             </a:r>
           </a:p>
           <a:p xmlns:a="http://schemas.openxmlformats.org/drawingml/2006/main">
@@ -911,7 +911,7 @@
           <a:lstStyle xmlns:a="http://schemas.openxmlformats.org/drawingml/2006/main"/>
           <a:p xmlns:a="http://schemas.openxmlformats.org/drawingml/2006/main">
             <a:r>
-              <a:t>Be transparent about the release gate. The local interface and tested flow are working. However, the local main branch has diverged from the recorded origin/main reference, and the working tree includes unrelated dataset and scratch changes. A careful sync and selective staging step is required before publication.</a:t>
+              <a:t>Explain that the release gate has been completed. The v0.4.0 work was integrated onto the latest origin/main, rebuilt, browser-tested, checked for release scope and then published as commit fd1ac31. Unrelated dataset edits and the older root-level presentation were deliberately excluded. The next step is controlled review with representatives from the test, PDK and cleanroom teams.</a:t>
             </a:r>
           </a:p>
           <a:p xmlns:a="http://schemas.openxmlformats.org/drawingml/2006/main">
@@ -926,12 +926,12 @@
           </a:p>
           <a:p xmlns:a="http://schemas.openxmlformats.org/drawingml/2006/main">
             <a:r>
-              <a:t>- docs/releases/v0.4.0/CHANGELOG.md</a:t>
-            </a:r>
-          </a:p>
-          <a:p xmlns:a="http://schemas.openxmlformats.org/drawingml/2006/main">
-            <a:r>
-              <a:t>- local git status and branch comparison on 21 August 2026</a:t>
+              <a:t>- docs/releases/v0.4.0/RELEASE_CHECKLIST.md</a:t>
+            </a:r>
+          </a:p>
+          <a:p xmlns:a="http://schemas.openxmlformats.org/drawingml/2006/main">
+            <a:r>
+              <a:t>- Git commit fd1ac311beec417e760cc58e78c38c61d73a238c</a:t>
             </a:r>
           </a:p>
         </p:txBody>
@@ -1829,7 +1829,7 @@
   </p:cSld>
   <p:clrMap bg1="lt1" tx1="dk1" bg2="lt2" tx2="dk2" accent1="accent1" accent2="accent2" accent3="accent3" accent4="accent4" accent5="accent5" accent6="accent6" hlink="hlink" folHlink="folHlink"/>
   <p:sldLayoutIdLst>
-    <p:sldLayoutId xmlns:r="http://schemas.openxmlformats.org/officeDocument/2006/relationships" id="2147483649" r:id="R43d35f2cde914460"/>
+    <p:sldLayoutId xmlns:r="http://schemas.openxmlformats.org/officeDocument/2006/relationships" id="2147483649" r:id="R510056261c8d4de2"/>
   </p:sldLayoutIdLst>
   <p:txStyles>
     <p:titleStyle>
@@ -2563,14 +2563,14 @@
       </p:sp>
       <p:pic>
         <p:nvPicPr>
-          <p:cNvPr id="18" name=""/>
+          <p:cNvPr id="21" name=""/>
           <p:cNvPicPr>
             <a:picLocks xmlns:a="http://schemas.openxmlformats.org/drawingml/2006/main" noChangeAspect="1"/>
           </p:cNvPicPr>
           <p:nvPr/>
         </p:nvPicPr>
         <p:blipFill>
-          <a:blip xmlns:r="http://schemas.openxmlformats.org/officeDocument/2006/relationships" xmlns:a="http://schemas.openxmlformats.org/drawingml/2006/main" r:embed="Rd804fa9070fe46c2"/>
+          <a:blip xmlns:r="http://schemas.openxmlformats.org/officeDocument/2006/relationships" xmlns:a="http://schemas.openxmlformats.org/drawingml/2006/main" r:embed="R6e6aa1e470ac4327"/>
           <a:stretch xmlns:a="http://schemas.openxmlformats.org/drawingml/2006/main"/>
         </p:blipFill>
         <p:spPr>
@@ -2618,6 +2618,7 @@
           <a:lstStyle xmlns:a="http://schemas.openxmlformats.org/drawingml/2006/main"/>
           <a:p xmlns:a="http://schemas.openxmlformats.org/drawingml/2006/main">
             <a:pPr algn="l">
+              <a:buNone/>
               <a:defRPr sz="4350" b="1">
                 <a:solidFill>
                   <a:srgbClr val="111A3B"/>
@@ -2641,6 +2642,7 @@
           </a:p>
           <a:p xmlns:a="http://schemas.openxmlformats.org/drawingml/2006/main">
             <a:pPr algn="l">
+              <a:buNone/>
               <a:defRPr sz="4350" b="1">
                 <a:solidFill>
                   <a:srgbClr val="111A3B"/>
@@ -2699,6 +2701,7 @@
           <a:lstStyle xmlns:a="http://schemas.openxmlformats.org/drawingml/2006/main"/>
           <a:p xmlns:a="http://schemas.openxmlformats.org/drawingml/2006/main">
             <a:pPr algn="l">
+              <a:buNone/>
               <a:defRPr sz="1875" b="0">
                 <a:solidFill>
                   <a:srgbClr val="66708D"/>
@@ -2752,11 +2755,12 @@
         </p:spPr>
         <p:txBody>
           <a:bodyPr xmlns:a="http://schemas.openxmlformats.org/drawingml/2006/main" lIns="0" tIns="0" rIns="0" bIns="0" anchor="t">
-            <a:normAutofit fontScale="100000"/>
+            <a:normAutofit fontScale="89056"/>
           </a:bodyPr>
           <a:lstStyle xmlns:a="http://schemas.openxmlformats.org/drawingml/2006/main"/>
           <a:p xmlns:a="http://schemas.openxmlformats.org/drawingml/2006/main">
             <a:pPr algn="l">
+              <a:buNone/>
               <a:defRPr sz="1275" b="1">
                 <a:solidFill>
                   <a:srgbClr val="38258A"/>
@@ -2775,21 +2779,22 @@
                 <a:ea typeface="Arial"/>
                 <a:cs typeface="Arial"/>
               </a:rPr>
-              <a:t>Team proposal and development overview · v0.4.0 · 21 August 2026</a:t>
+              <a:t>Created by Aiman Hazim Shafizam · Research Technician
+Testing and Characterisation · CORNERSTONE · v0.4.0 · 21 August 2026</a:t>
             </a:r>
           </a:p>
         </p:txBody>
       </p:sp>
       <p:pic>
         <p:nvPicPr>
-          <p:cNvPr id="22" name=""/>
+          <p:cNvPr id="25" name=""/>
           <p:cNvPicPr>
             <a:picLocks xmlns:a="http://schemas.openxmlformats.org/drawingml/2006/main" noChangeAspect="1"/>
           </p:cNvPicPr>
           <p:nvPr/>
         </p:nvPicPr>
         <p:blipFill>
-          <a:blip xmlns:r="http://schemas.openxmlformats.org/officeDocument/2006/relationships" xmlns:a="http://schemas.openxmlformats.org/drawingml/2006/main" r:embed="Rdcd52342211c490d"/>
+          <a:blip xmlns:r="http://schemas.openxmlformats.org/officeDocument/2006/relationships" xmlns:a="http://schemas.openxmlformats.org/drawingml/2006/main" r:embed="R80cd125b44ff4a3e"/>
           <a:stretch xmlns:a="http://schemas.openxmlformats.org/drawingml/2006/main"/>
         </p:blipFill>
         <p:spPr>
@@ -3045,6 +3050,7 @@
           <a:lstStyle xmlns:a="http://schemas.openxmlformats.org/drawingml/2006/main"/>
           <a:p xmlns:a="http://schemas.openxmlformats.org/drawingml/2006/main">
             <a:pPr algn="l">
+              <a:buNone/>
               <a:defRPr sz="1050" b="1">
                 <a:solidFill>
                   <a:srgbClr val="38258A"/>
@@ -3103,6 +3109,7 @@
           <a:lstStyle xmlns:a="http://schemas.openxmlformats.org/drawingml/2006/main"/>
           <a:p xmlns:a="http://schemas.openxmlformats.org/drawingml/2006/main">
             <a:pPr algn="l">
+              <a:buNone/>
               <a:defRPr sz="3000" b="1">
                 <a:solidFill>
                   <a:srgbClr val="111A3B"/>
@@ -3192,6 +3199,7 @@
           <a:lstStyle xmlns:a="http://schemas.openxmlformats.org/drawingml/2006/main"/>
           <a:p xmlns:a="http://schemas.openxmlformats.org/drawingml/2006/main">
             <a:pPr algn="l">
+              <a:buNone/>
               <a:defRPr sz="975" b="0">
                 <a:solidFill>
                   <a:srgbClr val="66708D"/>
@@ -3250,6 +3258,7 @@
           <a:lstStyle xmlns:a="http://schemas.openxmlformats.org/drawingml/2006/main"/>
           <a:p xmlns:a="http://schemas.openxmlformats.org/drawingml/2006/main">
             <a:pPr algn="r">
+              <a:buNone/>
               <a:defRPr sz="975" b="0">
                 <a:solidFill>
                   <a:srgbClr val="66708D"/>
@@ -3308,6 +3317,7 @@
           <a:lstStyle xmlns:a="http://schemas.openxmlformats.org/drawingml/2006/main"/>
           <a:p xmlns:a="http://schemas.openxmlformats.org/drawingml/2006/main">
             <a:pPr algn="l">
+              <a:buNone/>
               <a:defRPr sz="1800" b="1">
                 <a:solidFill>
                   <a:srgbClr val="66708D"/>
@@ -3366,6 +3376,7 @@
           <a:lstStyle xmlns:a="http://schemas.openxmlformats.org/drawingml/2006/main"/>
           <a:p xmlns:a="http://schemas.openxmlformats.org/drawingml/2006/main">
             <a:pPr algn="l">
+              <a:buNone/>
               <a:defRPr sz="1650" b="0">
                 <a:solidFill>
                   <a:srgbClr val="151A2F"/>
@@ -3424,6 +3435,7 @@
           <a:lstStyle xmlns:a="http://schemas.openxmlformats.org/drawingml/2006/main"/>
           <a:p xmlns:a="http://schemas.openxmlformats.org/drawingml/2006/main">
             <a:pPr algn="l">
+              <a:buNone/>
               <a:defRPr sz="1800" b="1">
                 <a:solidFill>
                   <a:srgbClr val="38258A"/>
@@ -3515,6 +3527,7 @@
           <a:lstStyle xmlns:a="http://schemas.openxmlformats.org/drawingml/2006/main"/>
           <a:p xmlns:a="http://schemas.openxmlformats.org/drawingml/2006/main">
             <a:pPr algn="l">
+              <a:buNone/>
               <a:defRPr sz="1575" b="0">
                 <a:solidFill>
                   <a:srgbClr val="151A2F"/>
@@ -3606,6 +3619,7 @@
           <a:lstStyle xmlns:a="http://schemas.openxmlformats.org/drawingml/2006/main"/>
           <a:p xmlns:a="http://schemas.openxmlformats.org/drawingml/2006/main">
             <a:pPr algn="l">
+              <a:buNone/>
               <a:defRPr sz="1575" b="0">
                 <a:solidFill>
                   <a:srgbClr val="151A2F"/>
@@ -3697,6 +3711,7 @@
           <a:lstStyle xmlns:a="http://schemas.openxmlformats.org/drawingml/2006/main"/>
           <a:p xmlns:a="http://schemas.openxmlformats.org/drawingml/2006/main">
             <a:pPr algn="l">
+              <a:buNone/>
               <a:defRPr sz="1575" b="0">
                 <a:solidFill>
                   <a:srgbClr val="151A2F"/>
@@ -3788,6 +3803,7 @@
           <a:lstStyle xmlns:a="http://schemas.openxmlformats.org/drawingml/2006/main"/>
           <a:p xmlns:a="http://schemas.openxmlformats.org/drawingml/2006/main">
             <a:pPr algn="l">
+              <a:buNone/>
               <a:defRPr sz="1575" b="0">
                 <a:solidFill>
                   <a:srgbClr val="151A2F"/>
@@ -3846,6 +3862,7 @@
           <a:lstStyle xmlns:a="http://schemas.openxmlformats.org/drawingml/2006/main"/>
           <a:p xmlns:a="http://schemas.openxmlformats.org/drawingml/2006/main">
             <a:pPr algn="ctr">
+              <a:buNone/>
               <a:defRPr sz="1875" b="1">
                 <a:solidFill>
                   <a:srgbClr val="111A3B"/>
@@ -4112,6 +4129,7 @@
           <a:lstStyle xmlns:a="http://schemas.openxmlformats.org/drawingml/2006/main"/>
           <a:p xmlns:a="http://schemas.openxmlformats.org/drawingml/2006/main">
             <a:pPr algn="l">
+              <a:buNone/>
               <a:defRPr sz="1050" b="1">
                 <a:solidFill>
                   <a:srgbClr val="38258A"/>
@@ -4170,6 +4188,7 @@
           <a:lstStyle xmlns:a="http://schemas.openxmlformats.org/drawingml/2006/main"/>
           <a:p xmlns:a="http://schemas.openxmlformats.org/drawingml/2006/main">
             <a:pPr algn="l">
+              <a:buNone/>
               <a:defRPr sz="3000" b="1">
                 <a:solidFill>
                   <a:srgbClr val="111A3B"/>
@@ -4259,6 +4278,7 @@
           <a:lstStyle xmlns:a="http://schemas.openxmlformats.org/drawingml/2006/main"/>
           <a:p xmlns:a="http://schemas.openxmlformats.org/drawingml/2006/main">
             <a:pPr algn="l">
+              <a:buNone/>
               <a:defRPr sz="975" b="0">
                 <a:solidFill>
                   <a:srgbClr val="66708D"/>
@@ -4317,6 +4337,7 @@
           <a:lstStyle xmlns:a="http://schemas.openxmlformats.org/drawingml/2006/main"/>
           <a:p xmlns:a="http://schemas.openxmlformats.org/drawingml/2006/main">
             <a:pPr algn="r">
+              <a:buNone/>
               <a:defRPr sz="975" b="0">
                 <a:solidFill>
                   <a:srgbClr val="66708D"/>
@@ -4375,6 +4396,7 @@
           <a:lstStyle xmlns:a="http://schemas.openxmlformats.org/drawingml/2006/main"/>
           <a:p xmlns:a="http://schemas.openxmlformats.org/drawingml/2006/main">
             <a:pPr algn="l">
+              <a:buNone/>
               <a:defRPr sz="1875" b="1">
                 <a:solidFill>
                   <a:srgbClr val="38258A"/>
@@ -4464,6 +4486,7 @@
           <a:lstStyle xmlns:a="http://schemas.openxmlformats.org/drawingml/2006/main"/>
           <a:p xmlns:a="http://schemas.openxmlformats.org/drawingml/2006/main">
             <a:pPr algn="l">
+              <a:buNone/>
               <a:defRPr sz="1575" b="0">
                 <a:solidFill>
                   <a:srgbClr val="151A2F"/>
@@ -4522,6 +4545,7 @@
           <a:lstStyle xmlns:a="http://schemas.openxmlformats.org/drawingml/2006/main"/>
           <a:p xmlns:a="http://schemas.openxmlformats.org/drawingml/2006/main">
             <a:pPr algn="l">
+              <a:buNone/>
               <a:defRPr sz="1875" b="1">
                 <a:solidFill>
                   <a:srgbClr val="38258A"/>
@@ -4611,6 +4635,7 @@
           <a:lstStyle xmlns:a="http://schemas.openxmlformats.org/drawingml/2006/main"/>
           <a:p xmlns:a="http://schemas.openxmlformats.org/drawingml/2006/main">
             <a:pPr algn="l">
+              <a:buNone/>
               <a:defRPr sz="1575" b="0">
                 <a:solidFill>
                   <a:srgbClr val="151A2F"/>
@@ -4669,6 +4694,7 @@
           <a:lstStyle xmlns:a="http://schemas.openxmlformats.org/drawingml/2006/main"/>
           <a:p xmlns:a="http://schemas.openxmlformats.org/drawingml/2006/main">
             <a:pPr algn="l">
+              <a:buNone/>
               <a:defRPr sz="1875" b="1">
                 <a:solidFill>
                   <a:srgbClr val="38258A"/>
@@ -4758,6 +4784,7 @@
           <a:lstStyle xmlns:a="http://schemas.openxmlformats.org/drawingml/2006/main"/>
           <a:p xmlns:a="http://schemas.openxmlformats.org/drawingml/2006/main">
             <a:pPr algn="l">
+              <a:buNone/>
               <a:defRPr sz="1575" b="0">
                 <a:solidFill>
                   <a:srgbClr val="151A2F"/>
@@ -4816,6 +4843,7 @@
           <a:lstStyle xmlns:a="http://schemas.openxmlformats.org/drawingml/2006/main"/>
           <a:p xmlns:a="http://schemas.openxmlformats.org/drawingml/2006/main">
             <a:pPr algn="ctr">
+              <a:buNone/>
               <a:defRPr sz="1950" b="1">
                 <a:solidFill>
                   <a:srgbClr val="111A3B"/>
@@ -5082,6 +5110,7 @@
           <a:lstStyle xmlns:a="http://schemas.openxmlformats.org/drawingml/2006/main"/>
           <a:p xmlns:a="http://schemas.openxmlformats.org/drawingml/2006/main">
             <a:pPr algn="l">
+              <a:buNone/>
               <a:defRPr sz="1050" b="1">
                 <a:solidFill>
                   <a:srgbClr val="38258A"/>
@@ -5140,6 +5169,7 @@
           <a:lstStyle xmlns:a="http://schemas.openxmlformats.org/drawingml/2006/main"/>
           <a:p xmlns:a="http://schemas.openxmlformats.org/drawingml/2006/main">
             <a:pPr algn="l">
+              <a:buNone/>
               <a:defRPr sz="3000" b="1">
                 <a:solidFill>
                   <a:srgbClr val="111A3B"/>
@@ -5229,6 +5259,7 @@
           <a:lstStyle xmlns:a="http://schemas.openxmlformats.org/drawingml/2006/main"/>
           <a:p xmlns:a="http://schemas.openxmlformats.org/drawingml/2006/main">
             <a:pPr algn="l">
+              <a:buNone/>
               <a:defRPr sz="975" b="0">
                 <a:solidFill>
                   <a:srgbClr val="66708D"/>
@@ -5287,6 +5318,7 @@
           <a:lstStyle xmlns:a="http://schemas.openxmlformats.org/drawingml/2006/main"/>
           <a:p xmlns:a="http://schemas.openxmlformats.org/drawingml/2006/main">
             <a:pPr algn="r">
+              <a:buNone/>
               <a:defRPr sz="975" b="0">
                 <a:solidFill>
                   <a:srgbClr val="66708D"/>
@@ -5345,6 +5377,7 @@
           <a:lstStyle xmlns:a="http://schemas.openxmlformats.org/drawingml/2006/main"/>
           <a:p xmlns:a="http://schemas.openxmlformats.org/drawingml/2006/main">
             <a:pPr algn="l">
+              <a:buNone/>
               <a:defRPr sz="1950" b="1">
                 <a:solidFill>
                   <a:srgbClr val="38258A"/>
@@ -5403,6 +5436,7 @@
           <a:lstStyle xmlns:a="http://schemas.openxmlformats.org/drawingml/2006/main"/>
           <a:p xmlns:a="http://schemas.openxmlformats.org/drawingml/2006/main">
             <a:pPr algn="l">
+              <a:buNone/>
               <a:defRPr sz="1650" b="0">
                 <a:solidFill>
                   <a:srgbClr val="151A2F"/>
@@ -5492,6 +5526,7 @@
           <a:lstStyle xmlns:a="http://schemas.openxmlformats.org/drawingml/2006/main"/>
           <a:p xmlns:a="http://schemas.openxmlformats.org/drawingml/2006/main">
             <a:pPr algn="l">
+              <a:buNone/>
               <a:defRPr sz="1950" b="1">
                 <a:solidFill>
                   <a:srgbClr val="38258A"/>
@@ -5583,6 +5618,7 @@
           <a:lstStyle xmlns:a="http://schemas.openxmlformats.org/drawingml/2006/main"/>
           <a:p xmlns:a="http://schemas.openxmlformats.org/drawingml/2006/main">
             <a:pPr algn="l">
+              <a:buNone/>
               <a:defRPr sz="1575" b="0">
                 <a:solidFill>
                   <a:srgbClr val="151A2F"/>
@@ -5674,6 +5710,7 @@
           <a:lstStyle xmlns:a="http://schemas.openxmlformats.org/drawingml/2006/main"/>
           <a:p xmlns:a="http://schemas.openxmlformats.org/drawingml/2006/main">
             <a:pPr algn="l">
+              <a:buNone/>
               <a:defRPr sz="1575" b="0">
                 <a:solidFill>
                   <a:srgbClr val="151A2F"/>
@@ -5765,6 +5802,7 @@
           <a:lstStyle xmlns:a="http://schemas.openxmlformats.org/drawingml/2006/main"/>
           <a:p xmlns:a="http://schemas.openxmlformats.org/drawingml/2006/main">
             <a:pPr algn="l">
+              <a:buNone/>
               <a:defRPr sz="1575" b="0">
                 <a:solidFill>
                   <a:srgbClr val="151A2F"/>
@@ -5823,6 +5861,7 @@
           <a:lstStyle xmlns:a="http://schemas.openxmlformats.org/drawingml/2006/main"/>
           <a:p xmlns:a="http://schemas.openxmlformats.org/drawingml/2006/main">
             <a:pPr algn="ctr">
+              <a:buNone/>
               <a:defRPr sz="1575" b="1">
                 <a:solidFill>
                   <a:srgbClr val="A66B00"/>
@@ -6089,6 +6128,7 @@
           <a:lstStyle xmlns:a="http://schemas.openxmlformats.org/drawingml/2006/main"/>
           <a:p xmlns:a="http://schemas.openxmlformats.org/drawingml/2006/main">
             <a:pPr algn="l">
+              <a:buNone/>
               <a:defRPr sz="1050" b="1">
                 <a:solidFill>
                   <a:srgbClr val="38258A"/>
@@ -6130,95 +6170,6 @@
           <a:xfrm xmlns:a="http://schemas.openxmlformats.org/drawingml/2006/main">
             <a:off x="533400" y="628650"/>
             <a:ext cx="11125200" cy="666750"/>
-          </a:xfrm>
-          <a:prstGeom xmlns:a="http://schemas.openxmlformats.org/drawingml/2006/main" prst="rect">
-            <a:avLst/>
-          </a:prstGeom>
-          <a:noFill xmlns:a="http://schemas.openxmlformats.org/drawingml/2006/main"/>
-          <a:ln xmlns:a="http://schemas.openxmlformats.org/drawingml/2006/main" w="0">
-            <a:noFill/>
-            <a:prstDash val="solid"/>
-          </a:ln>
-        </p:spPr>
-        <p:txBody>
-          <a:bodyPr xmlns:a="http://schemas.openxmlformats.org/drawingml/2006/main" lIns="0" tIns="0" rIns="0" bIns="0" anchor="t">
-            <a:normAutofit fontScale="85589"/>
-          </a:bodyPr>
-          <a:lstStyle xmlns:a="http://schemas.openxmlformats.org/drawingml/2006/main"/>
-          <a:p xmlns:a="http://schemas.openxmlformats.org/drawingml/2006/main">
-            <a:pPr algn="l">
-              <a:defRPr sz="3000" b="1">
-                <a:solidFill>
-                  <a:srgbClr val="111A3B"/>
-                </a:solidFill>
-                <a:latin typeface="Arial"/>
-                <a:ea typeface="Arial"/>
-                <a:cs typeface="Arial"/>
-              </a:defRPr>
-            </a:pPr>
-            <a:r>
-              <a:rPr sz="3000" b="1">
-                <a:solidFill>
-                  <a:srgbClr val="111A3B"/>
-                </a:solidFill>
-                <a:latin typeface="Arial"/>
-                <a:ea typeface="Arial"/>
-                <a:cs typeface="Arial"/>
-              </a:rPr>
-              <a:t>The suite progressed from an idea to a release candidate in eight weeks</a:t>
-            </a:r>
-          </a:p>
-        </p:txBody>
-      </p:sp>
-      <p:sp>
-        <p:nvSpPr>
-          <p:cNvPr id="9" name="">
-            <a:extLst xmlns:a="http://schemas.openxmlformats.org/drawingml/2006/main">
-              <a:ext uri="{FF2B5EF4-FFF2-40B4-BE49-F238E27FC236}">
-                <a16:creationId xmlns:a16="http://schemas.microsoft.com/office/drawing/2014/main" id="{F3A40A6D-375A-457C-87CD-E6CB9868AEDE}"/>
-              </a:ext>
-            </a:extLst>
-          </p:cNvPr>
-          <p:cNvSpPr>
-            <a:spLocks xmlns:a="http://schemas.openxmlformats.org/drawingml/2006/main" noGrp="1"/>
-          </p:cNvSpPr>
-          <p:nvPr/>
-        </p:nvSpPr>
-        <p:spPr>
-          <a:xfrm xmlns:a="http://schemas.openxmlformats.org/drawingml/2006/main">
-            <a:off x="533400" y="1390650"/>
-            <a:ext cx="11125200" cy="9525"/>
-          </a:xfrm>
-          <a:prstGeom xmlns:a="http://schemas.openxmlformats.org/drawingml/2006/main" prst="rect">
-            <a:avLst/>
-          </a:prstGeom>
-          <a:solidFill xmlns:a="http://schemas.openxmlformats.org/drawingml/2006/main">
-            <a:srgbClr val="D9DEEA"/>
-          </a:solidFill>
-          <a:ln xmlns:a="http://schemas.openxmlformats.org/drawingml/2006/main" w="0">
-            <a:noFill/>
-            <a:prstDash val="solid"/>
-          </a:ln>
-        </p:spPr>
-      </p:sp>
-      <p:sp>
-        <p:nvSpPr>
-          <p:cNvPr id="10" name="">
-            <a:extLst xmlns:a="http://schemas.openxmlformats.org/drawingml/2006/main">
-              <a:ext uri="{FF2B5EF4-FFF2-40B4-BE49-F238E27FC236}">
-                <a16:creationId xmlns:a16="http://schemas.microsoft.com/office/drawing/2014/main" id="{0B4EBD2C-DBC3-426B-9CED-B41F254E8CE6}"/>
-              </a:ext>
-            </a:extLst>
-          </p:cNvPr>
-          <p:cNvSpPr>
-            <a:spLocks xmlns:a="http://schemas.openxmlformats.org/drawingml/2006/main" noGrp="1"/>
-          </p:cNvSpPr>
-          <p:nvPr/>
-        </p:nvSpPr>
-        <p:spPr>
-          <a:xfrm xmlns:a="http://schemas.openxmlformats.org/drawingml/2006/main">
-            <a:off x="533400" y="6515100"/>
-            <a:ext cx="4762500" cy="190500"/>
           </a:xfrm>
           <a:prstGeom xmlns:a="http://schemas.openxmlformats.org/drawingml/2006/main" prst="rect">
             <a:avLst/>
@@ -6236,9 +6187,10 @@
           <a:lstStyle xmlns:a="http://schemas.openxmlformats.org/drawingml/2006/main"/>
           <a:p xmlns:a="http://schemas.openxmlformats.org/drawingml/2006/main">
             <a:pPr algn="l">
-              <a:defRPr sz="975" b="0">
-                <a:solidFill>
-                  <a:srgbClr val="66708D"/>
+              <a:buNone/>
+              <a:defRPr sz="3000" b="1">
+                <a:solidFill>
+                  <a:srgbClr val="111A3B"/>
                 </a:solidFill>
                 <a:latin typeface="Arial"/>
                 <a:ea typeface="Arial"/>
@@ -6246,37 +6198,68 @@
               </a:defRPr>
             </a:pPr>
             <a:r>
-              <a:rPr sz="975" b="0">
-                <a:solidFill>
-                  <a:srgbClr val="66708D"/>
+              <a:rPr sz="3000" b="1">
+                <a:solidFill>
+                  <a:srgbClr val="111A3B"/>
                 </a:solidFill>
                 <a:latin typeface="Arial"/>
                 <a:ea typeface="Arial"/>
                 <a:cs typeface="Arial"/>
               </a:rPr>
-              <a:t>CORNERSTONE | Wafer Post-Processing Suite</a:t>
-            </a:r>
-          </a:p>
-        </p:txBody>
-      </p:sp>
-      <p:sp>
-        <p:nvSpPr>
-          <p:cNvPr id="11" name="">
-            <a:extLst xmlns:a="http://schemas.openxmlformats.org/drawingml/2006/main">
-              <a:ext uri="{FF2B5EF4-FFF2-40B4-BE49-F238E27FC236}">
-                <a16:creationId xmlns:a16="http://schemas.microsoft.com/office/drawing/2014/main" id="{B8813266-0909-441B-9185-E65789AD8534}"/>
-              </a:ext>
-            </a:extLst>
-          </p:cNvPr>
-          <p:cNvSpPr>
-            <a:spLocks xmlns:a="http://schemas.openxmlformats.org/drawingml/2006/main" noGrp="1"/>
-          </p:cNvSpPr>
-          <p:nvPr/>
-        </p:nvSpPr>
-        <p:spPr>
-          <a:xfrm xmlns:a="http://schemas.openxmlformats.org/drawingml/2006/main">
-            <a:off x="11163300" y="6515100"/>
-            <a:ext cx="476250" cy="190500"/>
+              <a:t>The suite moved from idea to published v0.4.0 in eight weeks</a:t>
+            </a:r>
+          </a:p>
+        </p:txBody>
+      </p:sp>
+      <p:sp>
+        <p:nvSpPr>
+          <p:cNvPr id="9" name="">
+            <a:extLst xmlns:a="http://schemas.openxmlformats.org/drawingml/2006/main">
+              <a:ext uri="{FF2B5EF4-FFF2-40B4-BE49-F238E27FC236}">
+                <a16:creationId xmlns:a16="http://schemas.microsoft.com/office/drawing/2014/main" id="{F3A40A6D-375A-457C-87CD-E6CB9868AEDE}"/>
+              </a:ext>
+            </a:extLst>
+          </p:cNvPr>
+          <p:cNvSpPr>
+            <a:spLocks xmlns:a="http://schemas.openxmlformats.org/drawingml/2006/main" noGrp="1"/>
+          </p:cNvSpPr>
+          <p:nvPr/>
+        </p:nvSpPr>
+        <p:spPr>
+          <a:xfrm xmlns:a="http://schemas.openxmlformats.org/drawingml/2006/main">
+            <a:off x="533400" y="1390650"/>
+            <a:ext cx="11125200" cy="9525"/>
+          </a:xfrm>
+          <a:prstGeom xmlns:a="http://schemas.openxmlformats.org/drawingml/2006/main" prst="rect">
+            <a:avLst/>
+          </a:prstGeom>
+          <a:solidFill xmlns:a="http://schemas.openxmlformats.org/drawingml/2006/main">
+            <a:srgbClr val="D9DEEA"/>
+          </a:solidFill>
+          <a:ln xmlns:a="http://schemas.openxmlformats.org/drawingml/2006/main" w="0">
+            <a:noFill/>
+            <a:prstDash val="solid"/>
+          </a:ln>
+        </p:spPr>
+      </p:sp>
+      <p:sp>
+        <p:nvSpPr>
+          <p:cNvPr id="10" name="">
+            <a:extLst xmlns:a="http://schemas.openxmlformats.org/drawingml/2006/main">
+              <a:ext uri="{FF2B5EF4-FFF2-40B4-BE49-F238E27FC236}">
+                <a16:creationId xmlns:a16="http://schemas.microsoft.com/office/drawing/2014/main" id="{0B4EBD2C-DBC3-426B-9CED-B41F254E8CE6}"/>
+              </a:ext>
+            </a:extLst>
+          </p:cNvPr>
+          <p:cNvSpPr>
+            <a:spLocks xmlns:a="http://schemas.openxmlformats.org/drawingml/2006/main" noGrp="1"/>
+          </p:cNvSpPr>
+          <p:nvPr/>
+        </p:nvSpPr>
+        <p:spPr>
+          <a:xfrm xmlns:a="http://schemas.openxmlformats.org/drawingml/2006/main">
+            <a:off x="533400" y="6515100"/>
+            <a:ext cx="4762500" cy="190500"/>
           </a:xfrm>
           <a:prstGeom xmlns:a="http://schemas.openxmlformats.org/drawingml/2006/main" prst="rect">
             <a:avLst/>
@@ -6293,7 +6276,67 @@
           </a:bodyPr>
           <a:lstStyle xmlns:a="http://schemas.openxmlformats.org/drawingml/2006/main"/>
           <a:p xmlns:a="http://schemas.openxmlformats.org/drawingml/2006/main">
+            <a:pPr algn="l">
+              <a:buNone/>
+              <a:defRPr sz="975" b="0">
+                <a:solidFill>
+                  <a:srgbClr val="66708D"/>
+                </a:solidFill>
+                <a:latin typeface="Arial"/>
+                <a:ea typeface="Arial"/>
+                <a:cs typeface="Arial"/>
+              </a:defRPr>
+            </a:pPr>
+            <a:r>
+              <a:rPr sz="975" b="0">
+                <a:solidFill>
+                  <a:srgbClr val="66708D"/>
+                </a:solidFill>
+                <a:latin typeface="Arial"/>
+                <a:ea typeface="Arial"/>
+                <a:cs typeface="Arial"/>
+              </a:rPr>
+              <a:t>CORNERSTONE | Wafer Post-Processing Suite</a:t>
+            </a:r>
+          </a:p>
+        </p:txBody>
+      </p:sp>
+      <p:sp>
+        <p:nvSpPr>
+          <p:cNvPr id="11" name="">
+            <a:extLst xmlns:a="http://schemas.openxmlformats.org/drawingml/2006/main">
+              <a:ext uri="{FF2B5EF4-FFF2-40B4-BE49-F238E27FC236}">
+                <a16:creationId xmlns:a16="http://schemas.microsoft.com/office/drawing/2014/main" id="{B8813266-0909-441B-9185-E65789AD8534}"/>
+              </a:ext>
+            </a:extLst>
+          </p:cNvPr>
+          <p:cNvSpPr>
+            <a:spLocks xmlns:a="http://schemas.openxmlformats.org/drawingml/2006/main" noGrp="1"/>
+          </p:cNvSpPr>
+          <p:nvPr/>
+        </p:nvSpPr>
+        <p:spPr>
+          <a:xfrm xmlns:a="http://schemas.openxmlformats.org/drawingml/2006/main">
+            <a:off x="11163300" y="6515100"/>
+            <a:ext cx="476250" cy="190500"/>
+          </a:xfrm>
+          <a:prstGeom xmlns:a="http://schemas.openxmlformats.org/drawingml/2006/main" prst="rect">
+            <a:avLst/>
+          </a:prstGeom>
+          <a:noFill xmlns:a="http://schemas.openxmlformats.org/drawingml/2006/main"/>
+          <a:ln xmlns:a="http://schemas.openxmlformats.org/drawingml/2006/main" w="0">
+            <a:noFill/>
+            <a:prstDash val="solid"/>
+          </a:ln>
+        </p:spPr>
+        <p:txBody>
+          <a:bodyPr xmlns:a="http://schemas.openxmlformats.org/drawingml/2006/main" lIns="0" tIns="0" rIns="0" bIns="0" anchor="t">
+            <a:normAutofit fontScale="100000"/>
+          </a:bodyPr>
+          <a:lstStyle xmlns:a="http://schemas.openxmlformats.org/drawingml/2006/main"/>
+          <a:p xmlns:a="http://schemas.openxmlformats.org/drawingml/2006/main">
             <a:pPr algn="r">
+              <a:buNone/>
               <a:defRPr sz="975" b="0">
                 <a:solidFill>
                   <a:srgbClr val="66708D"/>
@@ -6416,6 +6459,7 @@
           <a:lstStyle xmlns:a="http://schemas.openxmlformats.org/drawingml/2006/main"/>
           <a:p xmlns:a="http://schemas.openxmlformats.org/drawingml/2006/main">
             <a:pPr algn="l">
+              <a:buNone/>
               <a:defRPr sz="1125" b="1">
                 <a:solidFill>
                   <a:srgbClr val="38258A"/>
@@ -6474,6 +6518,7 @@
           <a:lstStyle xmlns:a="http://schemas.openxmlformats.org/drawingml/2006/main"/>
           <a:p xmlns:a="http://schemas.openxmlformats.org/drawingml/2006/main">
             <a:pPr algn="l">
+              <a:buNone/>
               <a:defRPr sz="1500" b="1">
                 <a:solidFill>
                   <a:srgbClr val="111A3B"/>
@@ -6532,6 +6577,7 @@
           <a:lstStyle xmlns:a="http://schemas.openxmlformats.org/drawingml/2006/main"/>
           <a:p xmlns:a="http://schemas.openxmlformats.org/drawingml/2006/main">
             <a:pPr algn="l">
+              <a:buNone/>
               <a:defRPr sz="1200" b="0">
                 <a:solidFill>
                   <a:srgbClr val="66708D"/>
@@ -6623,6 +6669,7 @@
           <a:lstStyle xmlns:a="http://schemas.openxmlformats.org/drawingml/2006/main"/>
           <a:p xmlns:a="http://schemas.openxmlformats.org/drawingml/2006/main">
             <a:pPr algn="l">
+              <a:buNone/>
               <a:defRPr sz="1125" b="1">
                 <a:solidFill>
                   <a:srgbClr val="38258A"/>
@@ -6681,6 +6728,7 @@
           <a:lstStyle xmlns:a="http://schemas.openxmlformats.org/drawingml/2006/main"/>
           <a:p xmlns:a="http://schemas.openxmlformats.org/drawingml/2006/main">
             <a:pPr algn="l">
+              <a:buNone/>
               <a:defRPr sz="1500" b="1">
                 <a:solidFill>
                   <a:srgbClr val="111A3B"/>
@@ -6739,6 +6787,7 @@
           <a:lstStyle xmlns:a="http://schemas.openxmlformats.org/drawingml/2006/main"/>
           <a:p xmlns:a="http://schemas.openxmlformats.org/drawingml/2006/main">
             <a:pPr algn="l">
+              <a:buNone/>
               <a:defRPr sz="1200" b="0">
                 <a:solidFill>
                   <a:srgbClr val="66708D"/>
@@ -6830,6 +6879,7 @@
           <a:lstStyle xmlns:a="http://schemas.openxmlformats.org/drawingml/2006/main"/>
           <a:p xmlns:a="http://schemas.openxmlformats.org/drawingml/2006/main">
             <a:pPr algn="l">
+              <a:buNone/>
               <a:defRPr sz="1125" b="1">
                 <a:solidFill>
                   <a:srgbClr val="38258A"/>
@@ -6888,6 +6938,7 @@
           <a:lstStyle xmlns:a="http://schemas.openxmlformats.org/drawingml/2006/main"/>
           <a:p xmlns:a="http://schemas.openxmlformats.org/drawingml/2006/main">
             <a:pPr algn="l">
+              <a:buNone/>
               <a:defRPr sz="1500" b="1">
                 <a:solidFill>
                   <a:srgbClr val="111A3B"/>
@@ -6946,6 +6997,7 @@
           <a:lstStyle xmlns:a="http://schemas.openxmlformats.org/drawingml/2006/main"/>
           <a:p xmlns:a="http://schemas.openxmlformats.org/drawingml/2006/main">
             <a:pPr algn="l">
+              <a:buNone/>
               <a:defRPr sz="1200" b="0">
                 <a:solidFill>
                   <a:srgbClr val="66708D"/>
@@ -7037,6 +7089,7 @@
           <a:lstStyle xmlns:a="http://schemas.openxmlformats.org/drawingml/2006/main"/>
           <a:p xmlns:a="http://schemas.openxmlformats.org/drawingml/2006/main">
             <a:pPr algn="l">
+              <a:buNone/>
               <a:defRPr sz="1125" b="1">
                 <a:solidFill>
                   <a:srgbClr val="38258A"/>
@@ -7095,6 +7148,7 @@
           <a:lstStyle xmlns:a="http://schemas.openxmlformats.org/drawingml/2006/main"/>
           <a:p xmlns:a="http://schemas.openxmlformats.org/drawingml/2006/main">
             <a:pPr algn="l">
+              <a:buNone/>
               <a:defRPr sz="1500" b="1">
                 <a:solidFill>
                   <a:srgbClr val="111A3B"/>
@@ -7153,6 +7207,7 @@
           <a:lstStyle xmlns:a="http://schemas.openxmlformats.org/drawingml/2006/main"/>
           <a:p xmlns:a="http://schemas.openxmlformats.org/drawingml/2006/main">
             <a:pPr algn="l">
+              <a:buNone/>
               <a:defRPr sz="1200" b="0">
                 <a:solidFill>
                   <a:srgbClr val="66708D"/>
@@ -7244,6 +7299,7 @@
           <a:lstStyle xmlns:a="http://schemas.openxmlformats.org/drawingml/2006/main"/>
           <a:p xmlns:a="http://schemas.openxmlformats.org/drawingml/2006/main">
             <a:pPr algn="l">
+              <a:buNone/>
               <a:defRPr sz="1125" b="1">
                 <a:solidFill>
                   <a:srgbClr val="38258A"/>
@@ -7302,6 +7358,7 @@
           <a:lstStyle xmlns:a="http://schemas.openxmlformats.org/drawingml/2006/main"/>
           <a:p xmlns:a="http://schemas.openxmlformats.org/drawingml/2006/main">
             <a:pPr algn="l">
+              <a:buNone/>
               <a:defRPr sz="1500" b="1">
                 <a:solidFill>
                   <a:srgbClr val="111A3B"/>
@@ -7360,6 +7417,7 @@
           <a:lstStyle xmlns:a="http://schemas.openxmlformats.org/drawingml/2006/main"/>
           <a:p xmlns:a="http://schemas.openxmlformats.org/drawingml/2006/main">
             <a:pPr algn="l">
+              <a:buNone/>
               <a:defRPr sz="1200" b="0">
                 <a:solidFill>
                   <a:srgbClr val="66708D"/>
@@ -7451,6 +7509,7 @@
           <a:lstStyle xmlns:a="http://schemas.openxmlformats.org/drawingml/2006/main"/>
           <a:p xmlns:a="http://schemas.openxmlformats.org/drawingml/2006/main">
             <a:pPr algn="l">
+              <a:buNone/>
               <a:defRPr sz="1125" b="1">
                 <a:solidFill>
                   <a:srgbClr val="38258A"/>
@@ -7509,6 +7568,7 @@
           <a:lstStyle xmlns:a="http://schemas.openxmlformats.org/drawingml/2006/main"/>
           <a:p xmlns:a="http://schemas.openxmlformats.org/drawingml/2006/main">
             <a:pPr algn="l">
+              <a:buNone/>
               <a:defRPr sz="1500" b="1">
                 <a:solidFill>
                   <a:srgbClr val="111A3B"/>
@@ -7567,6 +7627,7 @@
           <a:lstStyle xmlns:a="http://schemas.openxmlformats.org/drawingml/2006/main"/>
           <a:p xmlns:a="http://schemas.openxmlformats.org/drawingml/2006/main">
             <a:pPr algn="l">
+              <a:buNone/>
               <a:defRPr sz="1200" b="0">
                 <a:solidFill>
                   <a:srgbClr val="66708D"/>
@@ -7833,6 +7894,7 @@
           <a:lstStyle xmlns:a="http://schemas.openxmlformats.org/drawingml/2006/main"/>
           <a:p xmlns:a="http://schemas.openxmlformats.org/drawingml/2006/main">
             <a:pPr algn="l">
+              <a:buNone/>
               <a:defRPr sz="1050" b="1">
                 <a:solidFill>
                   <a:srgbClr val="38258A"/>
@@ -7886,11 +7948,12 @@
         </p:spPr>
         <p:txBody>
           <a:bodyPr xmlns:a="http://schemas.openxmlformats.org/drawingml/2006/main" lIns="0" tIns="0" rIns="0" bIns="0" anchor="t">
-            <a:normAutofit fontScale="85679"/>
+            <a:normAutofit fontScale="85776"/>
           </a:bodyPr>
           <a:lstStyle xmlns:a="http://schemas.openxmlformats.org/drawingml/2006/main"/>
           <a:p xmlns:a="http://schemas.openxmlformats.org/drawingml/2006/main">
             <a:pPr algn="l">
+              <a:buNone/>
               <a:defRPr sz="3000" b="1">
                 <a:solidFill>
                   <a:srgbClr val="111A3B"/>
@@ -7909,7 +7972,7 @@
                 <a:ea typeface="Arial"/>
                 <a:cs typeface="Arial"/>
               </a:rPr>
-              <a:t>v0.4.0 is ready for controlled team review after one repository sync gate</a:t>
+              <a:t>v0.4.0 is published to GitHub main and ready for controlled team review</a:t>
             </a:r>
           </a:p>
         </p:txBody>
@@ -7980,6 +8043,7 @@
           <a:lstStyle xmlns:a="http://schemas.openxmlformats.org/drawingml/2006/main"/>
           <a:p xmlns:a="http://schemas.openxmlformats.org/drawingml/2006/main">
             <a:pPr algn="l">
+              <a:buNone/>
               <a:defRPr sz="975" b="0">
                 <a:solidFill>
                   <a:srgbClr val="66708D"/>
@@ -8038,6 +8102,7 @@
           <a:lstStyle xmlns:a="http://schemas.openxmlformats.org/drawingml/2006/main"/>
           <a:p xmlns:a="http://schemas.openxmlformats.org/drawingml/2006/main">
             <a:pPr algn="r">
+              <a:buNone/>
               <a:defRPr sz="975" b="0">
                 <a:solidFill>
                   <a:srgbClr val="66708D"/>
@@ -8096,6 +8161,7 @@
           <a:lstStyle xmlns:a="http://schemas.openxmlformats.org/drawingml/2006/main"/>
           <a:p xmlns:a="http://schemas.openxmlformats.org/drawingml/2006/main">
             <a:pPr algn="l">
+              <a:buNone/>
               <a:defRPr sz="1875" b="1">
                 <a:solidFill>
                   <a:srgbClr val="178A62"/>
@@ -8114,7 +8180,7 @@
                 <a:ea typeface="Arial"/>
                 <a:cs typeface="Arial"/>
               </a:rPr>
-              <a:t>Validated locally</a:t>
+              <a:t>Validated release</a:t>
             </a:r>
           </a:p>
         </p:txBody>
@@ -8187,6 +8253,7 @@
           <a:lstStyle xmlns:a="http://schemas.openxmlformats.org/drawingml/2006/main"/>
           <a:p xmlns:a="http://schemas.openxmlformats.org/drawingml/2006/main">
             <a:pPr algn="l">
+              <a:buNone/>
               <a:defRPr sz="1500" b="0">
                 <a:solidFill>
                   <a:srgbClr val="151A2F"/>
@@ -8278,6 +8345,7 @@
           <a:lstStyle xmlns:a="http://schemas.openxmlformats.org/drawingml/2006/main"/>
           <a:p xmlns:a="http://schemas.openxmlformats.org/drawingml/2006/main">
             <a:pPr algn="l">
+              <a:buNone/>
               <a:defRPr sz="1500" b="0">
                 <a:solidFill>
                   <a:srgbClr val="151A2F"/>
@@ -8369,6 +8437,7 @@
           <a:lstStyle xmlns:a="http://schemas.openxmlformats.org/drawingml/2006/main"/>
           <a:p xmlns:a="http://schemas.openxmlformats.org/drawingml/2006/main">
             <a:pPr algn="l">
+              <a:buNone/>
               <a:defRPr sz="1500" b="0">
                 <a:solidFill>
                   <a:srgbClr val="151A2F"/>
@@ -8460,6 +8529,7 @@
           <a:lstStyle xmlns:a="http://schemas.openxmlformats.org/drawingml/2006/main"/>
           <a:p xmlns:a="http://schemas.openxmlformats.org/drawingml/2006/main">
             <a:pPr algn="l">
+              <a:buNone/>
               <a:defRPr sz="1500" b="0">
                 <a:solidFill>
                   <a:srgbClr val="151A2F"/>
@@ -8518,6 +8588,7 @@
           <a:lstStyle xmlns:a="http://schemas.openxmlformats.org/drawingml/2006/main"/>
           <a:p xmlns:a="http://schemas.openxmlformats.org/drawingml/2006/main">
             <a:pPr algn="l">
+              <a:buNone/>
               <a:defRPr sz="1875" b="1">
                 <a:solidFill>
                   <a:srgbClr val="A66B00"/>
@@ -8536,7 +8607,7 @@
                 <a:ea typeface="Arial"/>
                 <a:cs typeface="Arial"/>
               </a:rPr>
-              <a:t>Before publication</a:t>
+              <a:t>Published safely</a:t>
             </a:r>
           </a:p>
         </p:txBody>
@@ -8609,6 +8680,7 @@
           <a:lstStyle xmlns:a="http://schemas.openxmlformats.org/drawingml/2006/main"/>
           <a:p xmlns:a="http://schemas.openxmlformats.org/drawingml/2006/main">
             <a:pPr algn="l">
+              <a:buNone/>
               <a:defRPr sz="1500" b="0">
                 <a:solidFill>
                   <a:srgbClr val="151A2F"/>
@@ -8627,7 +8699,7 @@
                 <a:ea typeface="Arial"/>
                 <a:cs typeface="Arial"/>
               </a:rPr>
-              <a:t>Reconcile local main with the newer origin/main history</a:t>
+              <a:t>Integrated with the latest origin/main history</a:t>
             </a:r>
           </a:p>
         </p:txBody>
@@ -8700,6 +8772,7 @@
           <a:lstStyle xmlns:a="http://schemas.openxmlformats.org/drawingml/2006/main"/>
           <a:p xmlns:a="http://schemas.openxmlformats.org/drawingml/2006/main">
             <a:pPr algn="l">
+              <a:buNone/>
               <a:defRPr sz="1500" b="0">
                 <a:solidFill>
                   <a:srgbClr val="151A2F"/>
@@ -8718,7 +8791,7 @@
                 <a:ea typeface="Arial"/>
                 <a:cs typeface="Arial"/>
               </a:rPr>
-              <a:t>Review the mixed working tree and stage only approved release files</a:t>
+              <a:t>Kept unrelated dataset and scratch changes out of the release</a:t>
             </a:r>
           </a:p>
         </p:txBody>
@@ -8791,6 +8864,7 @@
           <a:lstStyle xmlns:a="http://schemas.openxmlformats.org/drawingml/2006/main"/>
           <a:p xmlns:a="http://schemas.openxmlformats.org/drawingml/2006/main">
             <a:pPr algn="l">
+              <a:buNone/>
               <a:defRPr sz="1500" b="0">
                 <a:solidFill>
                   <a:srgbClr val="151A2F"/>
@@ -8809,7 +8883,7 @@
                 <a:ea typeface="Arial"/>
                 <a:cs typeface="Arial"/>
               </a:rPr>
-              <a:t>Re-run build and smoke test after integration</a:t>
+              <a:t>Verified local main and origin/main at fd1ac31</a:t>
             </a:r>
           </a:p>
         </p:txBody>
@@ -8882,6 +8956,7 @@
           <a:lstStyle xmlns:a="http://schemas.openxmlformats.org/drawingml/2006/main"/>
           <a:p xmlns:a="http://schemas.openxmlformats.org/drawingml/2006/main">
             <a:pPr algn="l">
+              <a:buNone/>
               <a:defRPr sz="1500" b="0">
                 <a:solidFill>
                   <a:srgbClr val="151A2F"/>
@@ -8900,7 +8975,7 @@
                 <a:ea typeface="Arial"/>
                 <a:cs typeface="Arial"/>
               </a:rPr>
-              <a:t>Push only after the team approves the local candidate</a:t>
+              <a:t>Published to GitHub main on 21 August 2026</a:t>
             </a:r>
           </a:p>
         </p:txBody>
@@ -8940,6 +9015,7 @@
           <a:lstStyle xmlns:a="http://schemas.openxmlformats.org/drawingml/2006/main"/>
           <a:p xmlns:a="http://schemas.openxmlformats.org/drawingml/2006/main">
             <a:pPr algn="ctr">
+              <a:buNone/>
               <a:defRPr sz="1800" b="1">
                 <a:solidFill>
                   <a:srgbClr val="111A3B"/>
@@ -8958,7 +9034,7 @@
                 <a:ea typeface="Arial"/>
                 <a:cs typeface="Arial"/>
               </a:rPr>
-              <a:t>The application is functionally ready; the remaining risk is release integration, not the reviewed interface flow.</a:t>
+              <a:t>The application is published and functionally ready; the next step is controlled review with the test, PDK and cleanroom teams.</a:t>
             </a:r>
           </a:p>
         </p:txBody>
@@ -9213,6 +9289,7 @@
           <a:lstStyle xmlns:a="http://schemas.openxmlformats.org/drawingml/2006/main"/>
           <a:p xmlns:a="http://schemas.openxmlformats.org/drawingml/2006/main">
             <a:pPr algn="l">
+              <a:buNone/>
               <a:defRPr sz="1500" b="1">
                 <a:solidFill>
                   <a:srgbClr val="BFC8E8"/>
@@ -9271,6 +9348,7 @@
           <a:lstStyle xmlns:a="http://schemas.openxmlformats.org/drawingml/2006/main"/>
           <a:p xmlns:a="http://schemas.openxmlformats.org/drawingml/2006/main">
             <a:pPr algn="l">
+              <a:buNone/>
               <a:defRPr sz="3750" b="1">
                 <a:solidFill>
                   <a:srgbClr val="FFFFFF"/>
@@ -9360,6 +9438,7 @@
           <a:lstStyle xmlns:a="http://schemas.openxmlformats.org/drawingml/2006/main"/>
           <a:p xmlns:a="http://schemas.openxmlformats.org/drawingml/2006/main">
             <a:pPr algn="l">
+              <a:buNone/>
               <a:defRPr sz="1800" b="1">
                 <a:solidFill>
                   <a:srgbClr val="BFC8E8"/>
@@ -9418,6 +9497,7 @@
           <a:lstStyle xmlns:a="http://schemas.openxmlformats.org/drawingml/2006/main"/>
           <a:p xmlns:a="http://schemas.openxmlformats.org/drawingml/2006/main">
             <a:pPr algn="l">
+              <a:buNone/>
               <a:defRPr sz="1800" b="1">
                 <a:solidFill>
                   <a:srgbClr val="FFFFFF"/>
@@ -9476,6 +9556,7 @@
           <a:lstStyle xmlns:a="http://schemas.openxmlformats.org/drawingml/2006/main"/>
           <a:p xmlns:a="http://schemas.openxmlformats.org/drawingml/2006/main">
             <a:pPr algn="l">
+              <a:buNone/>
               <a:defRPr sz="1800" b="1">
                 <a:solidFill>
                   <a:srgbClr val="BFC8E8"/>
@@ -9534,6 +9615,7 @@
           <a:lstStyle xmlns:a="http://schemas.openxmlformats.org/drawingml/2006/main"/>
           <a:p xmlns:a="http://schemas.openxmlformats.org/drawingml/2006/main">
             <a:pPr algn="l">
+              <a:buNone/>
               <a:defRPr sz="1800" b="1">
                 <a:solidFill>
                   <a:srgbClr val="FFFFFF"/>
@@ -9592,6 +9674,7 @@
           <a:lstStyle xmlns:a="http://schemas.openxmlformats.org/drawingml/2006/main"/>
           <a:p xmlns:a="http://schemas.openxmlformats.org/drawingml/2006/main">
             <a:pPr algn="l">
+              <a:buNone/>
               <a:defRPr sz="1800" b="1">
                 <a:solidFill>
                   <a:srgbClr val="BFC8E8"/>
@@ -9650,6 +9733,7 @@
           <a:lstStyle xmlns:a="http://schemas.openxmlformats.org/drawingml/2006/main"/>
           <a:p xmlns:a="http://schemas.openxmlformats.org/drawingml/2006/main">
             <a:pPr algn="l">
+              <a:buNone/>
               <a:defRPr sz="1800" b="1">
                 <a:solidFill>
                   <a:srgbClr val="FFFFFF"/>
@@ -9708,6 +9792,7 @@
           <a:lstStyle xmlns:a="http://schemas.openxmlformats.org/drawingml/2006/main"/>
           <a:p xmlns:a="http://schemas.openxmlformats.org/drawingml/2006/main">
             <a:pPr algn="ctr">
+              <a:buNone/>
               <a:defRPr sz="1875" b="0">
                 <a:solidFill>
                   <a:srgbClr val="DCE3F8"/>
@@ -9974,6 +10059,7 @@
           <a:lstStyle xmlns:a="http://schemas.openxmlformats.org/drawingml/2006/main"/>
           <a:p xmlns:a="http://schemas.openxmlformats.org/drawingml/2006/main">
             <a:pPr algn="l">
+              <a:buNone/>
               <a:defRPr sz="1050" b="1">
                 <a:solidFill>
                   <a:srgbClr val="38258A"/>
@@ -10032,6 +10118,7 @@
           <a:lstStyle xmlns:a="http://schemas.openxmlformats.org/drawingml/2006/main"/>
           <a:p xmlns:a="http://schemas.openxmlformats.org/drawingml/2006/main">
             <a:pPr algn="l">
+              <a:buNone/>
               <a:defRPr sz="3000" b="1">
                 <a:solidFill>
                   <a:srgbClr val="111A3B"/>
@@ -10121,6 +10208,7 @@
           <a:lstStyle xmlns:a="http://schemas.openxmlformats.org/drawingml/2006/main"/>
           <a:p xmlns:a="http://schemas.openxmlformats.org/drawingml/2006/main">
             <a:pPr algn="l">
+              <a:buNone/>
               <a:defRPr sz="975" b="0">
                 <a:solidFill>
                   <a:srgbClr val="66708D"/>
@@ -10179,6 +10267,7 @@
           <a:lstStyle xmlns:a="http://schemas.openxmlformats.org/drawingml/2006/main"/>
           <a:p xmlns:a="http://schemas.openxmlformats.org/drawingml/2006/main">
             <a:pPr algn="r">
+              <a:buNone/>
               <a:defRPr sz="975" b="0">
                 <a:solidFill>
                   <a:srgbClr val="66708D"/>
@@ -10237,6 +10326,7 @@
           <a:lstStyle xmlns:a="http://schemas.openxmlformats.org/drawingml/2006/main"/>
           <a:p xmlns:a="http://schemas.openxmlformats.org/drawingml/2006/main">
             <a:pPr algn="l">
+              <a:buNone/>
               <a:defRPr sz="1800" b="1">
                 <a:solidFill>
                   <a:srgbClr val="38258A"/>
@@ -10295,6 +10385,7 @@
           <a:lstStyle xmlns:a="http://schemas.openxmlformats.org/drawingml/2006/main"/>
           <a:p xmlns:a="http://schemas.openxmlformats.org/drawingml/2006/main">
             <a:pPr algn="l">
+              <a:buNone/>
               <a:defRPr sz="1800" b="0">
                 <a:solidFill>
                   <a:srgbClr val="151A2F"/>
@@ -10417,6 +10508,7 @@
           <a:lstStyle xmlns:a="http://schemas.openxmlformats.org/drawingml/2006/main"/>
           <a:p xmlns:a="http://schemas.openxmlformats.org/drawingml/2006/main">
             <a:pPr algn="l">
+              <a:buNone/>
               <a:defRPr sz="1575" b="0">
                 <a:solidFill>
                   <a:srgbClr val="151A2F"/>
@@ -10508,6 +10600,7 @@
           <a:lstStyle xmlns:a="http://schemas.openxmlformats.org/drawingml/2006/main"/>
           <a:p xmlns:a="http://schemas.openxmlformats.org/drawingml/2006/main">
             <a:pPr algn="l">
+              <a:buNone/>
               <a:defRPr sz="1575" b="0">
                 <a:solidFill>
                   <a:srgbClr val="151A2F"/>
@@ -10599,6 +10692,7 @@
           <a:lstStyle xmlns:a="http://schemas.openxmlformats.org/drawingml/2006/main"/>
           <a:p xmlns:a="http://schemas.openxmlformats.org/drawingml/2006/main">
             <a:pPr algn="l">
+              <a:buNone/>
               <a:defRPr sz="1575" b="0">
                 <a:solidFill>
                   <a:srgbClr val="151A2F"/>
@@ -10690,6 +10784,7 @@
           <a:lstStyle xmlns:a="http://schemas.openxmlformats.org/drawingml/2006/main"/>
           <a:p xmlns:a="http://schemas.openxmlformats.org/drawingml/2006/main">
             <a:pPr algn="l">
+              <a:buNone/>
               <a:defRPr sz="1575" b="0">
                 <a:solidFill>
                   <a:srgbClr val="151A2F"/>
@@ -10956,6 +11051,7 @@
           <a:lstStyle xmlns:a="http://schemas.openxmlformats.org/drawingml/2006/main"/>
           <a:p xmlns:a="http://schemas.openxmlformats.org/drawingml/2006/main">
             <a:pPr algn="l">
+              <a:buNone/>
               <a:defRPr sz="1050" b="1">
                 <a:solidFill>
                   <a:srgbClr val="38258A"/>
@@ -11014,6 +11110,7 @@
           <a:lstStyle xmlns:a="http://schemas.openxmlformats.org/drawingml/2006/main"/>
           <a:p xmlns:a="http://schemas.openxmlformats.org/drawingml/2006/main">
             <a:pPr algn="l">
+              <a:buNone/>
               <a:defRPr sz="3000" b="1">
                 <a:solidFill>
                   <a:srgbClr val="111A3B"/>
@@ -11103,6 +11200,7 @@
           <a:lstStyle xmlns:a="http://schemas.openxmlformats.org/drawingml/2006/main"/>
           <a:p xmlns:a="http://schemas.openxmlformats.org/drawingml/2006/main">
             <a:pPr algn="l">
+              <a:buNone/>
               <a:defRPr sz="975" b="0">
                 <a:solidFill>
                   <a:srgbClr val="66708D"/>
@@ -11161,6 +11259,7 @@
           <a:lstStyle xmlns:a="http://schemas.openxmlformats.org/drawingml/2006/main"/>
           <a:p xmlns:a="http://schemas.openxmlformats.org/drawingml/2006/main">
             <a:pPr algn="r">
+              <a:buNone/>
               <a:defRPr sz="975" b="0">
                 <a:solidFill>
                   <a:srgbClr val="66708D"/>
@@ -11285,6 +11384,7 @@
           <a:lstStyle xmlns:a="http://schemas.openxmlformats.org/drawingml/2006/main"/>
           <a:p xmlns:a="http://schemas.openxmlformats.org/drawingml/2006/main">
             <a:pPr algn="l">
+              <a:buNone/>
               <a:defRPr sz="1275" b="1">
                 <a:solidFill>
                   <a:srgbClr val="38258A"/>
@@ -11343,6 +11443,7 @@
           <a:lstStyle xmlns:a="http://schemas.openxmlformats.org/drawingml/2006/main"/>
           <a:p xmlns:a="http://schemas.openxmlformats.org/drawingml/2006/main">
             <a:pPr algn="l">
+              <a:buNone/>
               <a:defRPr sz="1425" b="0">
                 <a:solidFill>
                   <a:srgbClr val="151A2F"/>
@@ -11467,6 +11568,7 @@
           <a:lstStyle xmlns:a="http://schemas.openxmlformats.org/drawingml/2006/main"/>
           <a:p xmlns:a="http://schemas.openxmlformats.org/drawingml/2006/main">
             <a:pPr algn="l">
+              <a:buNone/>
               <a:defRPr sz="1275" b="1">
                 <a:solidFill>
                   <a:srgbClr val="38258A"/>
@@ -11525,6 +11627,7 @@
           <a:lstStyle xmlns:a="http://schemas.openxmlformats.org/drawingml/2006/main"/>
           <a:p xmlns:a="http://schemas.openxmlformats.org/drawingml/2006/main">
             <a:pPr algn="l">
+              <a:buNone/>
               <a:defRPr sz="1425" b="0">
                 <a:solidFill>
                   <a:srgbClr val="151A2F"/>
@@ -11649,6 +11752,7 @@
           <a:lstStyle xmlns:a="http://schemas.openxmlformats.org/drawingml/2006/main"/>
           <a:p xmlns:a="http://schemas.openxmlformats.org/drawingml/2006/main">
             <a:pPr algn="l">
+              <a:buNone/>
               <a:defRPr sz="1275" b="1">
                 <a:solidFill>
                   <a:srgbClr val="38258A"/>
@@ -11707,6 +11811,7 @@
           <a:lstStyle xmlns:a="http://schemas.openxmlformats.org/drawingml/2006/main"/>
           <a:p xmlns:a="http://schemas.openxmlformats.org/drawingml/2006/main">
             <a:pPr algn="l">
+              <a:buNone/>
               <a:defRPr sz="1425" b="0">
                 <a:solidFill>
                   <a:srgbClr val="151A2F"/>
@@ -11831,6 +11936,7 @@
           <a:lstStyle xmlns:a="http://schemas.openxmlformats.org/drawingml/2006/main"/>
           <a:p xmlns:a="http://schemas.openxmlformats.org/drawingml/2006/main">
             <a:pPr algn="l">
+              <a:buNone/>
               <a:defRPr sz="1275" b="1">
                 <a:solidFill>
                   <a:srgbClr val="38258A"/>
@@ -11889,6 +11995,7 @@
           <a:lstStyle xmlns:a="http://schemas.openxmlformats.org/drawingml/2006/main"/>
           <a:p xmlns:a="http://schemas.openxmlformats.org/drawingml/2006/main">
             <a:pPr algn="l">
+              <a:buNone/>
               <a:defRPr sz="1425" b="0">
                 <a:solidFill>
                   <a:srgbClr val="151A2F"/>
@@ -11982,6 +12089,7 @@
           <a:lstStyle xmlns:a="http://schemas.openxmlformats.org/drawingml/2006/main"/>
           <a:p xmlns:a="http://schemas.openxmlformats.org/drawingml/2006/main">
             <a:pPr algn="l">
+              <a:buNone/>
               <a:defRPr sz="1275" b="1">
                 <a:solidFill>
                   <a:srgbClr val="38258A"/>
@@ -12040,6 +12148,7 @@
           <a:lstStyle xmlns:a="http://schemas.openxmlformats.org/drawingml/2006/main"/>
           <a:p xmlns:a="http://schemas.openxmlformats.org/drawingml/2006/main">
             <a:pPr algn="l">
+              <a:buNone/>
               <a:defRPr sz="1425" b="0">
                 <a:solidFill>
                   <a:srgbClr val="151A2F"/>
@@ -12098,6 +12207,7 @@
           <a:lstStyle xmlns:a="http://schemas.openxmlformats.org/drawingml/2006/main"/>
           <a:p xmlns:a="http://schemas.openxmlformats.org/drawingml/2006/main">
             <a:pPr algn="ctr">
+              <a:buNone/>
               <a:defRPr sz="1875" b="1">
                 <a:solidFill>
                   <a:srgbClr val="111A3B"/>
@@ -12364,6 +12474,7 @@
           <a:lstStyle xmlns:a="http://schemas.openxmlformats.org/drawingml/2006/main"/>
           <a:p xmlns:a="http://schemas.openxmlformats.org/drawingml/2006/main">
             <a:pPr algn="l">
+              <a:buNone/>
               <a:defRPr sz="1050" b="1">
                 <a:solidFill>
                   <a:srgbClr val="38258A"/>
@@ -12422,6 +12533,7 @@
           <a:lstStyle xmlns:a="http://schemas.openxmlformats.org/drawingml/2006/main"/>
           <a:p xmlns:a="http://schemas.openxmlformats.org/drawingml/2006/main">
             <a:pPr algn="l">
+              <a:buNone/>
               <a:defRPr sz="3000" b="1">
                 <a:solidFill>
                   <a:srgbClr val="111A3B"/>
@@ -12511,6 +12623,7 @@
           <a:lstStyle xmlns:a="http://schemas.openxmlformats.org/drawingml/2006/main"/>
           <a:p xmlns:a="http://schemas.openxmlformats.org/drawingml/2006/main">
             <a:pPr algn="l">
+              <a:buNone/>
               <a:defRPr sz="975" b="0">
                 <a:solidFill>
                   <a:srgbClr val="66708D"/>
@@ -12569,6 +12682,7 @@
           <a:lstStyle xmlns:a="http://schemas.openxmlformats.org/drawingml/2006/main"/>
           <a:p xmlns:a="http://schemas.openxmlformats.org/drawingml/2006/main">
             <a:pPr algn="r">
+              <a:buNone/>
               <a:defRPr sz="975" b="0">
                 <a:solidFill>
                   <a:srgbClr val="66708D"/>
@@ -12594,14 +12708,14 @@
       </p:sp>
       <p:pic>
         <p:nvPicPr>
-          <p:cNvPr id="28" name=""/>
+          <p:cNvPr id="31" name=""/>
           <p:cNvPicPr>
             <a:picLocks xmlns:a="http://schemas.openxmlformats.org/drawingml/2006/main" noChangeAspect="1"/>
           </p:cNvPicPr>
           <p:nvPr/>
         </p:nvPicPr>
         <p:blipFill>
-          <a:blip xmlns:r="http://schemas.openxmlformats.org/officeDocument/2006/relationships" xmlns:a="http://schemas.openxmlformats.org/drawingml/2006/main" r:embed="R2185e57d991842bd"/>
+          <a:blip xmlns:r="http://schemas.openxmlformats.org/officeDocument/2006/relationships" xmlns:a="http://schemas.openxmlformats.org/drawingml/2006/main" r:embed="R6120aecf0e5947ac"/>
           <a:stretch xmlns:a="http://schemas.openxmlformats.org/drawingml/2006/main"/>
         </p:blipFill>
         <p:spPr>
@@ -12616,14 +12730,14 @@
       </p:pic>
       <p:pic>
         <p:nvPicPr>
-          <p:cNvPr id="29" name=""/>
+          <p:cNvPr id="32" name=""/>
           <p:cNvPicPr>
             <a:picLocks xmlns:a="http://schemas.openxmlformats.org/drawingml/2006/main" noChangeAspect="1"/>
           </p:cNvPicPr>
           <p:nvPr/>
         </p:nvPicPr>
         <p:blipFill>
-          <a:blip xmlns:r="http://schemas.openxmlformats.org/officeDocument/2006/relationships" xmlns:a="http://schemas.openxmlformats.org/drawingml/2006/main" r:embed="Ra1e59f7bdab24275"/>
+          <a:blip xmlns:r="http://schemas.openxmlformats.org/officeDocument/2006/relationships" xmlns:a="http://schemas.openxmlformats.org/drawingml/2006/main" r:embed="Rf59260f358454749"/>
           <a:stretch xmlns:a="http://schemas.openxmlformats.org/drawingml/2006/main"/>
         </p:blipFill>
         <p:spPr>
@@ -12671,6 +12785,7 @@
           <a:lstStyle xmlns:a="http://schemas.openxmlformats.org/drawingml/2006/main"/>
           <a:p xmlns:a="http://schemas.openxmlformats.org/drawingml/2006/main">
             <a:pPr algn="l">
+              <a:buNone/>
               <a:defRPr sz="1650" b="1">
                 <a:solidFill>
                   <a:srgbClr val="66708D"/>
@@ -12729,6 +12844,7 @@
           <a:lstStyle xmlns:a="http://schemas.openxmlformats.org/drawingml/2006/main"/>
           <a:p xmlns:a="http://schemas.openxmlformats.org/drawingml/2006/main">
             <a:pPr algn="l">
+              <a:buNone/>
               <a:defRPr sz="1650" b="1">
                 <a:solidFill>
                   <a:srgbClr val="38258A"/>
@@ -12787,6 +12903,7 @@
           <a:lstStyle xmlns:a="http://schemas.openxmlformats.org/drawingml/2006/main"/>
           <a:p xmlns:a="http://schemas.openxmlformats.org/drawingml/2006/main">
             <a:pPr algn="ctr">
+              <a:buNone/>
               <a:defRPr sz="1350" b="1">
                 <a:solidFill>
                   <a:srgbClr val="111A3B"/>
@@ -13053,6 +13170,7 @@
           <a:lstStyle xmlns:a="http://schemas.openxmlformats.org/drawingml/2006/main"/>
           <a:p xmlns:a="http://schemas.openxmlformats.org/drawingml/2006/main">
             <a:pPr algn="l">
+              <a:buNone/>
               <a:defRPr sz="1050" b="1">
                 <a:solidFill>
                   <a:srgbClr val="38258A"/>
@@ -13111,6 +13229,7 @@
           <a:lstStyle xmlns:a="http://schemas.openxmlformats.org/drawingml/2006/main"/>
           <a:p xmlns:a="http://schemas.openxmlformats.org/drawingml/2006/main">
             <a:pPr algn="l">
+              <a:buNone/>
               <a:defRPr sz="3000" b="1">
                 <a:solidFill>
                   <a:srgbClr val="111A3B"/>
@@ -13200,6 +13319,7 @@
           <a:lstStyle xmlns:a="http://schemas.openxmlformats.org/drawingml/2006/main"/>
           <a:p xmlns:a="http://schemas.openxmlformats.org/drawingml/2006/main">
             <a:pPr algn="l">
+              <a:buNone/>
               <a:defRPr sz="975" b="0">
                 <a:solidFill>
                   <a:srgbClr val="66708D"/>
@@ -13258,6 +13378,7 @@
           <a:lstStyle xmlns:a="http://schemas.openxmlformats.org/drawingml/2006/main"/>
           <a:p xmlns:a="http://schemas.openxmlformats.org/drawingml/2006/main">
             <a:pPr algn="r">
+              <a:buNone/>
               <a:defRPr sz="975" b="0">
                 <a:solidFill>
                   <a:srgbClr val="66708D"/>
@@ -13283,14 +13404,14 @@
       </p:sp>
       <p:pic>
         <p:nvPicPr>
-          <p:cNvPr id="33" name=""/>
+          <p:cNvPr id="35" name=""/>
           <p:cNvPicPr>
             <a:picLocks xmlns:a="http://schemas.openxmlformats.org/drawingml/2006/main" noChangeAspect="1"/>
           </p:cNvPicPr>
           <p:nvPr/>
         </p:nvPicPr>
         <p:blipFill>
-          <a:blip xmlns:r="http://schemas.openxmlformats.org/officeDocument/2006/relationships" xmlns:a="http://schemas.openxmlformats.org/drawingml/2006/main" r:embed="R8a63e62552e54585"/>
+          <a:blip xmlns:r="http://schemas.openxmlformats.org/officeDocument/2006/relationships" xmlns:a="http://schemas.openxmlformats.org/drawingml/2006/main" r:embed="R15c4ab68b8ae4af2"/>
           <a:srcRect xmlns:a="http://schemas.openxmlformats.org/drawingml/2006/main" l="4176" t="0" r="4176" b="0"/>
           <a:stretch xmlns:a="http://schemas.openxmlformats.org/drawingml/2006/main">
             <a:fillRect l="0" t="0" r="0" b="0"/>
@@ -13341,6 +13462,7 @@
           <a:lstStyle xmlns:a="http://schemas.openxmlformats.org/drawingml/2006/main"/>
           <a:p xmlns:a="http://schemas.openxmlformats.org/drawingml/2006/main">
             <a:pPr algn="l">
+              <a:buNone/>
               <a:defRPr sz="1800" b="1">
                 <a:solidFill>
                   <a:srgbClr val="38258A"/>
@@ -13432,6 +13554,7 @@
           <a:lstStyle xmlns:a="http://schemas.openxmlformats.org/drawingml/2006/main"/>
           <a:p xmlns:a="http://schemas.openxmlformats.org/drawingml/2006/main">
             <a:pPr algn="l">
+              <a:buNone/>
               <a:defRPr sz="1425" b="0">
                 <a:solidFill>
                   <a:srgbClr val="151A2F"/>
@@ -13523,6 +13646,7 @@
           <a:lstStyle xmlns:a="http://schemas.openxmlformats.org/drawingml/2006/main"/>
           <a:p xmlns:a="http://schemas.openxmlformats.org/drawingml/2006/main">
             <a:pPr algn="l">
+              <a:buNone/>
               <a:defRPr sz="1425" b="0">
                 <a:solidFill>
                   <a:srgbClr val="151A2F"/>
@@ -13614,6 +13738,7 @@
           <a:lstStyle xmlns:a="http://schemas.openxmlformats.org/drawingml/2006/main"/>
           <a:p xmlns:a="http://schemas.openxmlformats.org/drawingml/2006/main">
             <a:pPr algn="l">
+              <a:buNone/>
               <a:defRPr sz="1425" b="0">
                 <a:solidFill>
                   <a:srgbClr val="151A2F"/>
@@ -13705,6 +13830,7 @@
           <a:lstStyle xmlns:a="http://schemas.openxmlformats.org/drawingml/2006/main"/>
           <a:p xmlns:a="http://schemas.openxmlformats.org/drawingml/2006/main">
             <a:pPr algn="l">
+              <a:buNone/>
               <a:defRPr sz="1425" b="0">
                 <a:solidFill>
                   <a:srgbClr val="151A2F"/>
@@ -13971,6 +14097,7 @@
           <a:lstStyle xmlns:a="http://schemas.openxmlformats.org/drawingml/2006/main"/>
           <a:p xmlns:a="http://schemas.openxmlformats.org/drawingml/2006/main">
             <a:pPr algn="l">
+              <a:buNone/>
               <a:defRPr sz="1050" b="1">
                 <a:solidFill>
                   <a:srgbClr val="38258A"/>
@@ -14029,6 +14156,7 @@
           <a:lstStyle xmlns:a="http://schemas.openxmlformats.org/drawingml/2006/main"/>
           <a:p xmlns:a="http://schemas.openxmlformats.org/drawingml/2006/main">
             <a:pPr algn="l">
+              <a:buNone/>
               <a:defRPr sz="3000" b="1">
                 <a:solidFill>
                   <a:srgbClr val="111A3B"/>
@@ -14118,6 +14246,7 @@
           <a:lstStyle xmlns:a="http://schemas.openxmlformats.org/drawingml/2006/main"/>
           <a:p xmlns:a="http://schemas.openxmlformats.org/drawingml/2006/main">
             <a:pPr algn="l">
+              <a:buNone/>
               <a:defRPr sz="975" b="0">
                 <a:solidFill>
                   <a:srgbClr val="66708D"/>
@@ -14176,6 +14305,7 @@
           <a:lstStyle xmlns:a="http://schemas.openxmlformats.org/drawingml/2006/main"/>
           <a:p xmlns:a="http://schemas.openxmlformats.org/drawingml/2006/main">
             <a:pPr algn="r">
+              <a:buNone/>
               <a:defRPr sz="975" b="0">
                 <a:solidFill>
                   <a:srgbClr val="66708D"/>
@@ -14201,14 +14331,14 @@
       </p:sp>
       <p:pic>
         <p:nvPicPr>
-          <p:cNvPr id="29" name=""/>
+          <p:cNvPr id="32" name=""/>
           <p:cNvPicPr>
             <a:picLocks xmlns:a="http://schemas.openxmlformats.org/drawingml/2006/main" noChangeAspect="1"/>
           </p:cNvPicPr>
           <p:nvPr/>
         </p:nvPicPr>
         <p:blipFill>
-          <a:blip xmlns:r="http://schemas.openxmlformats.org/officeDocument/2006/relationships" xmlns:a="http://schemas.openxmlformats.org/drawingml/2006/main" r:embed="R730824953a974b0d"/>
+          <a:blip xmlns:r="http://schemas.openxmlformats.org/officeDocument/2006/relationships" xmlns:a="http://schemas.openxmlformats.org/drawingml/2006/main" r:embed="R2cae4931d6d848b2"/>
           <a:srcRect xmlns:a="http://schemas.openxmlformats.org/drawingml/2006/main" l="0" t="30321" r="0" b="30321"/>
           <a:stretch xmlns:a="http://schemas.openxmlformats.org/drawingml/2006/main">
             <a:fillRect l="0" t="0" r="0" b="0"/>
@@ -14226,14 +14356,14 @@
       </p:pic>
       <p:pic>
         <p:nvPicPr>
-          <p:cNvPr id="30" name=""/>
+          <p:cNvPr id="33" name=""/>
           <p:cNvPicPr>
             <a:picLocks xmlns:a="http://schemas.openxmlformats.org/drawingml/2006/main" noChangeAspect="1"/>
           </p:cNvPicPr>
           <p:nvPr/>
         </p:nvPicPr>
         <p:blipFill>
-          <a:blip xmlns:r="http://schemas.openxmlformats.org/officeDocument/2006/relationships" xmlns:a="http://schemas.openxmlformats.org/drawingml/2006/main" r:embed="R5837e2608f0f4206"/>
+          <a:blip xmlns:r="http://schemas.openxmlformats.org/officeDocument/2006/relationships" xmlns:a="http://schemas.openxmlformats.org/drawingml/2006/main" r:embed="Rafea63ef8b274a67"/>
           <a:srcRect xmlns:a="http://schemas.openxmlformats.org/drawingml/2006/main" l="0" t="30321" r="0" b="30321"/>
           <a:stretch xmlns:a="http://schemas.openxmlformats.org/drawingml/2006/main">
             <a:fillRect l="0" t="0" r="0" b="0"/>
@@ -14284,6 +14414,7 @@
           <a:lstStyle xmlns:a="http://schemas.openxmlformats.org/drawingml/2006/main"/>
           <a:p xmlns:a="http://schemas.openxmlformats.org/drawingml/2006/main">
             <a:pPr algn="l">
+              <a:buNone/>
               <a:defRPr sz="1725" b="1">
                 <a:solidFill>
                   <a:srgbClr val="38258A"/>
@@ -14342,6 +14473,7 @@
           <a:lstStyle xmlns:a="http://schemas.openxmlformats.org/drawingml/2006/main"/>
           <a:p xmlns:a="http://schemas.openxmlformats.org/drawingml/2006/main">
             <a:pPr algn="l">
+              <a:buNone/>
               <a:defRPr sz="1425" b="0">
                 <a:solidFill>
                   <a:srgbClr val="151A2F"/>
@@ -14400,6 +14532,7 @@
           <a:lstStyle xmlns:a="http://schemas.openxmlformats.org/drawingml/2006/main"/>
           <a:p xmlns:a="http://schemas.openxmlformats.org/drawingml/2006/main">
             <a:pPr algn="l">
+              <a:buNone/>
               <a:defRPr sz="1725" b="1">
                 <a:solidFill>
                   <a:srgbClr val="38258A"/>
@@ -14458,6 +14591,7 @@
           <a:lstStyle xmlns:a="http://schemas.openxmlformats.org/drawingml/2006/main"/>
           <a:p xmlns:a="http://schemas.openxmlformats.org/drawingml/2006/main">
             <a:pPr algn="l">
+              <a:buNone/>
               <a:defRPr sz="1425" b="0">
                 <a:solidFill>
                   <a:srgbClr val="151A2F"/>
@@ -14724,6 +14858,7 @@
           <a:lstStyle xmlns:a="http://schemas.openxmlformats.org/drawingml/2006/main"/>
           <a:p xmlns:a="http://schemas.openxmlformats.org/drawingml/2006/main">
             <a:pPr algn="l">
+              <a:buNone/>
               <a:defRPr sz="1050" b="1">
                 <a:solidFill>
                   <a:srgbClr val="38258A"/>
@@ -14782,6 +14917,7 @@
           <a:lstStyle xmlns:a="http://schemas.openxmlformats.org/drawingml/2006/main"/>
           <a:p xmlns:a="http://schemas.openxmlformats.org/drawingml/2006/main">
             <a:pPr algn="l">
+              <a:buNone/>
               <a:defRPr sz="3000" b="1">
                 <a:solidFill>
                   <a:srgbClr val="111A3B"/>
@@ -14871,6 +15007,7 @@
           <a:lstStyle xmlns:a="http://schemas.openxmlformats.org/drawingml/2006/main"/>
           <a:p xmlns:a="http://schemas.openxmlformats.org/drawingml/2006/main">
             <a:pPr algn="l">
+              <a:buNone/>
               <a:defRPr sz="975" b="0">
                 <a:solidFill>
                   <a:srgbClr val="66708D"/>
@@ -14929,6 +15066,7 @@
           <a:lstStyle xmlns:a="http://schemas.openxmlformats.org/drawingml/2006/main"/>
           <a:p xmlns:a="http://schemas.openxmlformats.org/drawingml/2006/main">
             <a:pPr algn="r">
+              <a:buNone/>
               <a:defRPr sz="975" b="0">
                 <a:solidFill>
                   <a:srgbClr val="66708D"/>
@@ -14987,6 +15125,7 @@
           <a:lstStyle xmlns:a="http://schemas.openxmlformats.org/drawingml/2006/main"/>
           <a:p xmlns:a="http://schemas.openxmlformats.org/drawingml/2006/main">
             <a:pPr algn="l">
+              <a:buNone/>
               <a:defRPr sz="2025" b="1">
                 <a:solidFill>
                   <a:srgbClr val="38258A"/>
@@ -15076,6 +15215,7 @@
           <a:lstStyle xmlns:a="http://schemas.openxmlformats.org/drawingml/2006/main"/>
           <a:p xmlns:a="http://schemas.openxmlformats.org/drawingml/2006/main">
             <a:pPr algn="l">
+              <a:buNone/>
               <a:defRPr sz="1575" b="1">
                 <a:solidFill>
                   <a:srgbClr val="111A3B"/>
@@ -15134,6 +15274,7 @@
           <a:lstStyle xmlns:a="http://schemas.openxmlformats.org/drawingml/2006/main"/>
           <a:p xmlns:a="http://schemas.openxmlformats.org/drawingml/2006/main">
             <a:pPr algn="l">
+              <a:buNone/>
               <a:defRPr sz="1500" b="0">
                 <a:solidFill>
                   <a:srgbClr val="151A2F"/>
@@ -15192,6 +15333,7 @@
           <a:lstStyle xmlns:a="http://schemas.openxmlformats.org/drawingml/2006/main"/>
           <a:p xmlns:a="http://schemas.openxmlformats.org/drawingml/2006/main">
             <a:pPr algn="l">
+              <a:buNone/>
               <a:defRPr sz="2025" b="1">
                 <a:solidFill>
                   <a:srgbClr val="38258A"/>
@@ -15281,6 +15423,7 @@
           <a:lstStyle xmlns:a="http://schemas.openxmlformats.org/drawingml/2006/main"/>
           <a:p xmlns:a="http://schemas.openxmlformats.org/drawingml/2006/main">
             <a:pPr algn="l">
+              <a:buNone/>
               <a:defRPr sz="1575" b="1">
                 <a:solidFill>
                   <a:srgbClr val="111A3B"/>
@@ -15339,6 +15482,7 @@
           <a:lstStyle xmlns:a="http://schemas.openxmlformats.org/drawingml/2006/main"/>
           <a:p xmlns:a="http://schemas.openxmlformats.org/drawingml/2006/main">
             <a:pPr algn="l">
+              <a:buNone/>
               <a:defRPr sz="1500" b="0">
                 <a:solidFill>
                   <a:srgbClr val="151A2F"/>
@@ -15397,6 +15541,7 @@
           <a:lstStyle xmlns:a="http://schemas.openxmlformats.org/drawingml/2006/main"/>
           <a:p xmlns:a="http://schemas.openxmlformats.org/drawingml/2006/main">
             <a:pPr algn="l">
+              <a:buNone/>
               <a:defRPr sz="2025" b="1">
                 <a:solidFill>
                   <a:srgbClr val="38258A"/>
@@ -15486,6 +15631,7 @@
           <a:lstStyle xmlns:a="http://schemas.openxmlformats.org/drawingml/2006/main"/>
           <a:p xmlns:a="http://schemas.openxmlformats.org/drawingml/2006/main">
             <a:pPr algn="l">
+              <a:buNone/>
               <a:defRPr sz="1575" b="1">
                 <a:solidFill>
                   <a:srgbClr val="111A3B"/>
@@ -15544,6 +15690,7 @@
           <a:lstStyle xmlns:a="http://schemas.openxmlformats.org/drawingml/2006/main"/>
           <a:p xmlns:a="http://schemas.openxmlformats.org/drawingml/2006/main">
             <a:pPr algn="l">
+              <a:buNone/>
               <a:defRPr sz="1500" b="0">
                 <a:solidFill>
                   <a:srgbClr val="151A2F"/>
@@ -15602,6 +15749,7 @@
           <a:lstStyle xmlns:a="http://schemas.openxmlformats.org/drawingml/2006/main"/>
           <a:p xmlns:a="http://schemas.openxmlformats.org/drawingml/2006/main">
             <a:pPr algn="ctr">
+              <a:buNone/>
               <a:defRPr sz="1725" b="1">
                 <a:solidFill>
                   <a:srgbClr val="111A3B"/>
@@ -15868,6 +16016,7 @@
           <a:lstStyle xmlns:a="http://schemas.openxmlformats.org/drawingml/2006/main"/>
           <a:p xmlns:a="http://schemas.openxmlformats.org/drawingml/2006/main">
             <a:pPr algn="l">
+              <a:buNone/>
               <a:defRPr sz="1050" b="1">
                 <a:solidFill>
                   <a:srgbClr val="38258A"/>
@@ -15926,6 +16075,7 @@
           <a:lstStyle xmlns:a="http://schemas.openxmlformats.org/drawingml/2006/main"/>
           <a:p xmlns:a="http://schemas.openxmlformats.org/drawingml/2006/main">
             <a:pPr algn="l">
+              <a:buNone/>
               <a:defRPr sz="3000" b="1">
                 <a:solidFill>
                   <a:srgbClr val="111A3B"/>
@@ -16015,6 +16165,7 @@
           <a:lstStyle xmlns:a="http://schemas.openxmlformats.org/drawingml/2006/main"/>
           <a:p xmlns:a="http://schemas.openxmlformats.org/drawingml/2006/main">
             <a:pPr algn="l">
+              <a:buNone/>
               <a:defRPr sz="975" b="0">
                 <a:solidFill>
                   <a:srgbClr val="66708D"/>
@@ -16073,6 +16224,7 @@
           <a:lstStyle xmlns:a="http://schemas.openxmlformats.org/drawingml/2006/main"/>
           <a:p xmlns:a="http://schemas.openxmlformats.org/drawingml/2006/main">
             <a:pPr algn="r">
+              <a:buNone/>
               <a:defRPr sz="975" b="0">
                 <a:solidFill>
                   <a:srgbClr val="66708D"/>
@@ -16131,6 +16283,7 @@
           <a:lstStyle xmlns:a="http://schemas.openxmlformats.org/drawingml/2006/main"/>
           <a:p xmlns:a="http://schemas.openxmlformats.org/drawingml/2006/main">
             <a:pPr algn="l">
+              <a:buNone/>
               <a:defRPr sz="1800" b="1">
                 <a:solidFill>
                   <a:srgbClr val="38258A"/>
@@ -16222,6 +16375,7 @@
           <a:lstStyle xmlns:a="http://schemas.openxmlformats.org/drawingml/2006/main"/>
           <a:p xmlns:a="http://schemas.openxmlformats.org/drawingml/2006/main">
             <a:pPr algn="l">
+              <a:buNone/>
               <a:defRPr sz="1500" b="0">
                 <a:solidFill>
                   <a:srgbClr val="151A2F"/>
@@ -16313,6 +16467,7 @@
           <a:lstStyle xmlns:a="http://schemas.openxmlformats.org/drawingml/2006/main"/>
           <a:p xmlns:a="http://schemas.openxmlformats.org/drawingml/2006/main">
             <a:pPr algn="l">
+              <a:buNone/>
               <a:defRPr sz="1500" b="0">
                 <a:solidFill>
                   <a:srgbClr val="151A2F"/>
@@ -16404,6 +16559,7 @@
           <a:lstStyle xmlns:a="http://schemas.openxmlformats.org/drawingml/2006/main"/>
           <a:p xmlns:a="http://schemas.openxmlformats.org/drawingml/2006/main">
             <a:pPr algn="l">
+              <a:buNone/>
               <a:defRPr sz="1500" b="0">
                 <a:solidFill>
                   <a:srgbClr val="151A2F"/>
@@ -16462,6 +16618,7 @@
           <a:lstStyle xmlns:a="http://schemas.openxmlformats.org/drawingml/2006/main"/>
           <a:p xmlns:a="http://schemas.openxmlformats.org/drawingml/2006/main">
             <a:pPr algn="l">
+              <a:buNone/>
               <a:defRPr sz="1800" b="1">
                 <a:solidFill>
                   <a:srgbClr val="38258A"/>
@@ -16553,6 +16710,7 @@
           <a:lstStyle xmlns:a="http://schemas.openxmlformats.org/drawingml/2006/main"/>
           <a:p xmlns:a="http://schemas.openxmlformats.org/drawingml/2006/main">
             <a:pPr algn="l">
+              <a:buNone/>
               <a:defRPr sz="1500" b="0">
                 <a:solidFill>
                   <a:srgbClr val="151A2F"/>
@@ -16644,6 +16802,7 @@
           <a:lstStyle xmlns:a="http://schemas.openxmlformats.org/drawingml/2006/main"/>
           <a:p xmlns:a="http://schemas.openxmlformats.org/drawingml/2006/main">
             <a:pPr algn="l">
+              <a:buNone/>
               <a:defRPr sz="1500" b="0">
                 <a:solidFill>
                   <a:srgbClr val="151A2F"/>
@@ -16735,6 +16894,7 @@
           <a:lstStyle xmlns:a="http://schemas.openxmlformats.org/drawingml/2006/main"/>
           <a:p xmlns:a="http://schemas.openxmlformats.org/drawingml/2006/main">
             <a:pPr algn="l">
+              <a:buNone/>
               <a:defRPr sz="1500" b="0">
                 <a:solidFill>
                   <a:srgbClr val="151A2F"/>
@@ -16824,6 +16984,7 @@
           <a:lstStyle xmlns:a="http://schemas.openxmlformats.org/drawingml/2006/main"/>
           <a:p xmlns:a="http://schemas.openxmlformats.org/drawingml/2006/main">
             <a:pPr algn="ctr">
+              <a:buNone/>
               <a:defRPr sz="1875" b="1">
                 <a:solidFill>
                   <a:srgbClr val="111A3B"/>
@@ -17090,6 +17251,7 @@
           <a:lstStyle xmlns:a="http://schemas.openxmlformats.org/drawingml/2006/main"/>
           <a:p xmlns:a="http://schemas.openxmlformats.org/drawingml/2006/main">
             <a:pPr algn="l">
+              <a:buNone/>
               <a:defRPr sz="1050" b="1">
                 <a:solidFill>
                   <a:srgbClr val="38258A"/>
@@ -17148,6 +17310,7 @@
           <a:lstStyle xmlns:a="http://schemas.openxmlformats.org/drawingml/2006/main"/>
           <a:p xmlns:a="http://schemas.openxmlformats.org/drawingml/2006/main">
             <a:pPr algn="l">
+              <a:buNone/>
               <a:defRPr sz="3000" b="1">
                 <a:solidFill>
                   <a:srgbClr val="111A3B"/>
@@ -17237,6 +17400,7 @@
           <a:lstStyle xmlns:a="http://schemas.openxmlformats.org/drawingml/2006/main"/>
           <a:p xmlns:a="http://schemas.openxmlformats.org/drawingml/2006/main">
             <a:pPr algn="l">
+              <a:buNone/>
               <a:defRPr sz="975" b="0">
                 <a:solidFill>
                   <a:srgbClr val="66708D"/>
@@ -17295,6 +17459,7 @@
           <a:lstStyle xmlns:a="http://schemas.openxmlformats.org/drawingml/2006/main"/>
           <a:p xmlns:a="http://schemas.openxmlformats.org/drawingml/2006/main">
             <a:pPr algn="r">
+              <a:buNone/>
               <a:defRPr sz="975" b="0">
                 <a:solidFill>
                   <a:srgbClr val="66708D"/>
@@ -17320,14 +17485,14 @@
       </p:sp>
       <p:pic>
         <p:nvPicPr>
-          <p:cNvPr id="33" name=""/>
+          <p:cNvPr id="35" name=""/>
           <p:cNvPicPr>
             <a:picLocks xmlns:a="http://schemas.openxmlformats.org/drawingml/2006/main" noChangeAspect="1"/>
           </p:cNvPicPr>
           <p:nvPr/>
         </p:nvPicPr>
         <p:blipFill>
-          <a:blip xmlns:r="http://schemas.openxmlformats.org/officeDocument/2006/relationships" xmlns:a="http://schemas.openxmlformats.org/drawingml/2006/main" r:embed="R6ecdbe04f77541dd"/>
+          <a:blip xmlns:r="http://schemas.openxmlformats.org/officeDocument/2006/relationships" xmlns:a="http://schemas.openxmlformats.org/drawingml/2006/main" r:embed="R15eed98add5e41ed"/>
           <a:stretch xmlns:a="http://schemas.openxmlformats.org/drawingml/2006/main"/>
         </p:blipFill>
         <p:spPr>
@@ -17375,6 +17540,7 @@
           <a:lstStyle xmlns:a="http://schemas.openxmlformats.org/drawingml/2006/main"/>
           <a:p xmlns:a="http://schemas.openxmlformats.org/drawingml/2006/main">
             <a:pPr algn="l">
+              <a:buNone/>
               <a:defRPr sz="1800" b="1">
                 <a:solidFill>
                   <a:srgbClr val="38258A"/>
@@ -17466,6 +17632,7 @@
           <a:lstStyle xmlns:a="http://schemas.openxmlformats.org/drawingml/2006/main"/>
           <a:p xmlns:a="http://schemas.openxmlformats.org/drawingml/2006/main">
             <a:pPr algn="l">
+              <a:buNone/>
               <a:defRPr sz="1500" b="0">
                 <a:solidFill>
                   <a:srgbClr val="151A2F"/>
@@ -17557,6 +17724,7 @@
           <a:lstStyle xmlns:a="http://schemas.openxmlformats.org/drawingml/2006/main"/>
           <a:p xmlns:a="http://schemas.openxmlformats.org/drawingml/2006/main">
             <a:pPr algn="l">
+              <a:buNone/>
               <a:defRPr sz="1500" b="0">
                 <a:solidFill>
                   <a:srgbClr val="151A2F"/>
@@ -17648,6 +17816,7 @@
           <a:lstStyle xmlns:a="http://schemas.openxmlformats.org/drawingml/2006/main"/>
           <a:p xmlns:a="http://schemas.openxmlformats.org/drawingml/2006/main">
             <a:pPr algn="l">
+              <a:buNone/>
               <a:defRPr sz="1500" b="0">
                 <a:solidFill>
                   <a:srgbClr val="151A2F"/>
@@ -17739,6 +17908,7 @@
           <a:lstStyle xmlns:a="http://schemas.openxmlformats.org/drawingml/2006/main"/>
           <a:p xmlns:a="http://schemas.openxmlformats.org/drawingml/2006/main">
             <a:pPr algn="l">
+              <a:buNone/>
               <a:defRPr sz="1500" b="0">
                 <a:solidFill>
                   <a:srgbClr val="151A2F"/>

</xml_diff>